<commit_message>
LSA Climatology L19-L21 and FS1 rewritten along the syllabus in the validated style
Co-Authored-By: Claude Opus 5.5 <noreply@anthropic.com>
Claude-Session: https://claude.ai/code/session_0115LFSb2ktGLWPeVksFkSer
</commit_message>
<xml_diff>
--- a/lecons/LSA/Climatology/03_LSA_CLIM_L20_Micro_climates.pptx
+++ b/lecons/LSA/Climatology/03_LSA_CLIM_L20_Micro_climates.pptx
@@ -65,9 +65,13 @@
     <p:sldId id="313" r:id="rId59"/>
     <p:sldId id="314" r:id="rId60"/>
     <p:sldId id="315" r:id="rId61"/>
+    <p:sldId id="316" r:id="rId62"/>
+    <p:sldId id="317" r:id="rId63"/>
+    <p:sldId id="318" r:id="rId64"/>
+    <p:sldId id="319" r:id="rId65"/>
   </p:sldIdLst>
   <p:notesMasterIdLst>
-    <p:notesMasterId r:id="rId62"/>
+    <p:notesMasterId r:id="rId66"/>
   </p:notesMasterIdLst>
   <p:sldSz cx="12192000" cy="6858000"/>
   <p:notesSz cx="6858000" cy="12192000"/>
@@ -3201,7 +3205,7 @@
           <a:p>
             <a:r>
               <a:rPr lang="en-US" dirty="0"/>
-              <a:t>We continue with the definitions. On this slide we have Urban heat island and Anthropogenic heat. Write each point on a new line, with the key term first, and explain it in your own words when we revise. When you finish, we go to the next slide.</a:t>
+              <a:t>We continue with the definitions. On this slide we have Meso-climate and Heat island. Write each point on a new line, with the key term first, and explain it in your own words when we revise. When you finish, we go to the next slide.</a:t>
             </a:r>
             <a:endParaRPr lang="en-US" dirty="0"/>
           </a:p>
@@ -3289,7 +3293,7 @@
           <a:p>
             <a:r>
               <a:rPr lang="en-US" dirty="0"/>
-              <a:t>We continue with the definitions. On this slide we have Evapotranspiration. Write each point on a new line, with the key term first, and explain it in your own words when we revise.</a:t>
+              <a:t>We continue with the definitions. On this slide we have Anthropogenic heat. Write each point on a new line, with the key term first, and explain it in your own words when we revise.</a:t>
             </a:r>
             <a:endParaRPr lang="en-US" dirty="0"/>
           </a:p>
@@ -3377,7 +3381,7 @@
           <a:p>
             <a:r>
               <a:rPr lang="en-US" dirty="0"/>
-              <a:t>Let us copy Meaning and Classification of Micro-climates. Micro-climates are classified as follows. Copy the point on Urban climate on the left, then draw the diagram on the right: types of micro-climates. Give it a title and label it clearly.</a:t>
+              <a:t>Let us copy Meaning of Micro-climates. Micro-climates are explained as follows. Copy the point on Micro-climate on the left, then draw the diagram on the right: types of micro-climates. Give it a title and label it clearly.</a:t>
             </a:r>
             <a:endParaRPr lang="en-US" dirty="0"/>
           </a:p>
@@ -3553,7 +3557,7 @@
           <a:p>
             <a:r>
               <a:rPr lang="en-US" dirty="0"/>
-              <a:t>We continue with Meaning and Classification of Micro-climates. On this slide we have Mountain climate. Write each point on a new line, with the key term first, and explain it in your own words when we revise.</a:t>
+              <a:t>We continue with Meaning of Micro-climates. Copy the point on Micro- and meso-climates: write the key term first, then its explanation.</a:t>
             </a:r>
             <a:endParaRPr lang="en-US" dirty="0"/>
           </a:p>
@@ -3641,7 +3645,7 @@
           <a:p>
             <a:r>
               <a:rPr lang="en-US" dirty="0"/>
-              <a:t>Copy the point on Lakeside climate on the left, then draw the diagram on the right: a lakeside. Give it a title and label it clearly.</a:t>
+              <a:t>Let us copy Classification of Micro-climates. Micro-climates are classified into the following types. Copy the point on Urban climate on the left, then draw the diagram on the right: douala. Give it a title and label it clearly.</a:t>
             </a:r>
             <a:endParaRPr lang="en-US" dirty="0"/>
           </a:p>
@@ -3729,7 +3733,7 @@
           <a:p>
             <a:r>
               <a:rPr lang="en-US" dirty="0"/>
-              <a:t>Copy the point on Forest climate on the left, then draw the diagram on the right: a forest. Give it a title and label it clearly.</a:t>
+              <a:t>We continue with Classification of Micro-climates. Copy the point on Mountain climate: write the key term first, then its explanation.</a:t>
             </a:r>
             <a:endParaRPr lang="en-US" dirty="0"/>
           </a:p>
@@ -3817,7 +3821,7 @@
           <a:p>
             <a:r>
               <a:rPr lang="en-US" dirty="0"/>
-              <a:t>Let us copy Characteristics of Urban Climates. Compared with the countryside, towns have the following characteristics. Copy the point on Higher temperatures on the left, then draw the diagram on the right: the urban heat island. Give it a title and label it clearly.</a:t>
+              <a:t>Copy the point on Lakeside climate on the left, then draw the diagram on the right: a lake shore. Give it a title and label it clearly.</a:t>
             </a:r>
             <a:endParaRPr lang="en-US" dirty="0"/>
           </a:p>
@@ -3905,7 +3909,7 @@
           <a:p>
             <a:r>
               <a:rPr lang="en-US" dirty="0"/>
-              <a:t>We continue with Characteristics of Urban Climates. On this slide we have Lower humidity, Different winds and More pollution. Write each point on a new line, with the key term first, and explain it in your own words when we revise.</a:t>
+              <a:t>Copy the point on Forest climate on the left, then draw the diagram on the right: a forest. Give it a title and label it clearly.</a:t>
             </a:r>
             <a:endParaRPr lang="en-US" dirty="0"/>
           </a:p>
@@ -3993,7 +3997,7 @@
           <a:p>
             <a:r>
               <a:rPr lang="en-US" dirty="0"/>
-              <a:t>Copy the point on Slightly more rain on the left, then draw the diagram on the right: town and countryside compared. Give it a title and label it clearly.</a:t>
+              <a:t>Let us copy Characteristics of Urban Climates. Compared with the countryside, towns have the following climatic characteristics. Copy the point on Higher temperatures on the left, then draw the diagram on the right: the urban heat island. Give it a title and label it clearly.</a:t>
             </a:r>
             <a:endParaRPr lang="en-US" dirty="0"/>
           </a:p>
@@ -4081,7 +4085,7 @@
           <a:p>
             <a:r>
               <a:rPr lang="en-US" dirty="0"/>
-              <a:t>Let us copy Factors of the Urban Heat Island. The urban heat island is caused by the following factors. Copy the point on Surfaces on the left, then draw the diagram on the right: a large city. Give it a title and label it clearly.</a:t>
+              <a:t>We continue with Characteristics of Urban Climates. Copy the point on Lower humidity: write the key term first, then its explanation.</a:t>
             </a:r>
             <a:endParaRPr lang="en-US" dirty="0"/>
           </a:p>
@@ -4169,7 +4173,7 @@
           <a:p>
             <a:r>
               <a:rPr lang="en-US" dirty="0"/>
-              <a:t>We continue with Factors of the Urban Heat Island. On this slide we have Anthropogenic heat and Reduced evapotranspiration. Write each point on a new line, with the key term first, and explain it in your own words when we revise. When you finish, we go to the next slide.</a:t>
+              <a:t>We continue with Characteristics of Urban Climates. Copy the point on Modified winds: write the key term first, then its explanation.</a:t>
             </a:r>
             <a:endParaRPr lang="en-US" dirty="0"/>
           </a:p>
@@ -4257,7 +4261,7 @@
           <a:p>
             <a:r>
               <a:rPr lang="en-US" dirty="0"/>
-              <a:t>We continue with Factors of the Urban Heat Island. On this slide we have Urban geometry and Solutions. Write each point on a new line, with the key term first, and explain it in your own words when we revise.</a:t>
+              <a:t>Copy the point on More pollution and more rain on the left, then draw the diagram on the right: the urban climate. Give it a title and label it clearly.</a:t>
             </a:r>
             <a:endParaRPr lang="en-US" dirty="0"/>
           </a:p>
@@ -4345,7 +4349,7 @@
           <a:p>
             <a:r>
               <a:rPr lang="en-US" dirty="0"/>
-              <a:t>Now let us check what you have understood. Question 1: What is the urban heat island, and give two of its causes in Garoua? Answer in your exercise book.</a:t>
+              <a:t>Let us copy Factors of Urban Climates. The urban climate is explained by the following factors. Copy the point on Artificial surfaces: write the key term first, then its explanation.</a:t>
             </a:r>
             <a:endParaRPr lang="en-US" dirty="0"/>
           </a:p>
@@ -4521,7 +4525,7 @@
           <a:p>
             <a:r>
               <a:rPr lang="en-US" dirty="0"/>
-              <a:t>The expected answer is: the town is warmer than the countryside; causes: tar and concrete, heat from vehicles and generators, few trees (any two). If you got it right, well done.</a:t>
+              <a:t>We continue with Factors of Urban Climates. Copy the point on Anthropogenic heat: write the key term first, then its explanation.</a:t>
             </a:r>
             <a:endParaRPr lang="en-US" dirty="0"/>
           </a:p>
@@ -4609,7 +4613,7 @@
           <a:p>
             <a:r>
               <a:rPr lang="en-US" dirty="0"/>
-              <a:t>Now let us check what you have understood. Question 2: Give two differences between an urban climate and a rural climate. Answer in your exercise book.</a:t>
+              <a:t>We continue with Factors of Urban Climates. Copy the point on Reduced evapotranspiration: write the key term first, then its explanation.</a:t>
             </a:r>
             <a:endParaRPr lang="en-US" dirty="0"/>
           </a:p>
@@ -4697,7 +4701,7 @@
           <a:p>
             <a:r>
               <a:rPr lang="en-US" dirty="0"/>
-              <a:t>The expected answer is: towns are warmer, drier, less windy and more polluted (any two). If you got it right, well done.</a:t>
+              <a:t>We continue with Factors of Urban Climates. Copy the point on Urban geometry: write the key term first, then its explanation.</a:t>
             </a:r>
             <a:endParaRPr lang="en-US" dirty="0"/>
           </a:p>
@@ -4785,7 +4789,7 @@
           <a:p>
             <a:r>
               <a:rPr lang="en-US" dirty="0"/>
-              <a:t>For those who need more practice, fill in the blanks in your exercise book. The answers are: number 1, micro-climate; number 2, island; number 3, anthropogenic.</a:t>
+              <a:t>Now let us check what you have understood. Question 1: What is the urban heat island, and give two of its causes in Garoua? Answer in your exercise book.</a:t>
             </a:r>
             <a:endParaRPr lang="en-US" dirty="0"/>
           </a:p>
@@ -4873,7 +4877,7 @@
           <a:p>
             <a:r>
               <a:rPr lang="en-US" dirty="0"/>
-              <a:t>For your homework: State how temperature changes with altitude. We shall correct it at the beginning of our next lesson.</a:t>
+              <a:t>The expected answer is: the town is warmer than the countryside; causes: tar and concrete, heat from vehicles and generators, few trees (any two). If you got it right, well done.</a:t>
             </a:r>
             <a:endParaRPr lang="en-US" dirty="0"/>
           </a:p>
@@ -4961,7 +4965,7 @@
           <a:p>
             <a:r>
               <a:rPr lang="en-US" dirty="0"/>
-              <a:t>Our next lesson will be on Lesson 21: Mountain Climates. Thank you for your attention, and see you next time.</a:t>
+              <a:t>Now let us check what you have understood. Question 2: Give two differences between an urban climate and a rural climate. Answer in your exercise book.</a:t>
             </a:r>
             <a:endParaRPr lang="en-US" dirty="0"/>
           </a:p>
@@ -5049,7 +5053,7 @@
           <a:p>
             <a:r>
               <a:rPr lang="en-US" dirty="0"/>
-              <a:t>Let us play the bilingual game. I say a word in English, and you give me the French word. Then we do the reverse.</a:t>
+              <a:t>The expected answer is: towns are warmer, drier, less windy and more polluted (any two). If you got it right, well done.</a:t>
             </a:r>
             <a:endParaRPr lang="en-US" dirty="0"/>
           </a:p>
@@ -5137,7 +5141,7 @@
           <a:p>
             <a:r>
               <a:rPr lang="en-US" dirty="0"/>
-              <a:t>I record this information in the official logbook of the class after the lesson.</a:t>
+              <a:t>For those who need more practice, fill in the blanks in your exercise book. The answers are: number 1, micro-climate; number 2, island; number 3, anthropogenic.</a:t>
             </a:r>
             <a:endParaRPr lang="en-US" dirty="0"/>
           </a:p>
@@ -5225,7 +5229,7 @@
           <a:p>
             <a:r>
               <a:rPr lang="en-US" dirty="0"/>
-              <a:t>I complete the second page of the logbook: the matter taught, the evaluation, the homework and the attendance.</a:t>
+              <a:t>For your homework: State how temperature changes with altitude. We shall correct it at the beginning of our next lesson.</a:t>
             </a:r>
             <a:endParaRPr lang="en-US" dirty="0"/>
           </a:p>
@@ -5313,7 +5317,7 @@
           <a:p>
             <a:r>
               <a:rPr lang="en-US" dirty="0"/>
-              <a:t>This slide is for me, the teacher: it gives the timing of the lesson and what to do if the projector is not available.</a:t>
+              <a:t>Our next lesson will be on Lesson 21: Mountain Climates. Thank you for your attention, and see you next time.</a:t>
             </a:r>
             <a:endParaRPr lang="en-US" dirty="0"/>
           </a:p>
@@ -5489,7 +5493,7 @@
           <a:p>
             <a:r>
               <a:rPr lang="en-US" dirty="0"/>
-              <a:t>These are the references and picture credits used to prepare this lesson.</a:t>
+              <a:t>Let us play the bilingual game. I say a word in English, and you give me the French word. Then we do the reverse.</a:t>
             </a:r>
             <a:endParaRPr lang="en-US" dirty="0"/>
           </a:p>
@@ -5513,6 +5517,358 @@
             <a:fld id="{F7021451-1387-4CA6-816F-3879F97B5CBC}" type="slidenum">
               <a:rPr lang="en-US"/>
               <a:t>60</a:t>
+            </a:fld>
+            <a:endParaRPr lang="en-US"/>
+          </a:p>
+        </p:txBody>
+      </p:sp>
+    </p:spTree>
+    <p:extLst>
+      <p:ext uri="{BB962C8B-B14F-4D97-AF65-F5344CB8AC3E}">
+        <p14:creationId xmlns:p14="http://schemas.microsoft.com/office/powerpoint/2010/main" val="1024086991"/>
+      </p:ext>
+    </p:extLst>
+  </p:cSld>
+  <p:clrMapOvr>
+    <a:masterClrMapping/>
+  </p:clrMapOvr>
+</p:notes>
+</file>
+
+<file path=ppt/notesSlides/notesSlide61.xml><?xml version="1.0" encoding="utf-8"?>
+<p:notes xmlns:a="http://schemas.openxmlformats.org/drawingml/2006/main" xmlns:r="http://schemas.openxmlformats.org/officeDocument/2006/relationships" xmlns:p="http://schemas.openxmlformats.org/presentationml/2006/main">
+  <p:cSld>
+    <p:spTree>
+      <p:nvGrpSpPr>
+        <p:cNvPr id="1" name=""/>
+        <p:cNvGrpSpPr/>
+        <p:nvPr/>
+      </p:nvGrpSpPr>
+      <p:grpSpPr>
+        <a:xfrm>
+          <a:off x="0" y="0"/>
+          <a:ext cx="0" cy="0"/>
+          <a:chOff x="0" y="0"/>
+          <a:chExt cx="0" cy="0"/>
+        </a:xfrm>
+      </p:grpSpPr>
+      <p:sp>
+        <p:nvSpPr>
+          <p:cNvPr id="2" name="Slide Image Placeholder 1"/>
+          <p:cNvSpPr>
+            <a:spLocks noGrp="1" noRot="1" noChangeAspect="1"/>
+          </p:cNvSpPr>
+          <p:nvPr>
+            <p:ph type="sldImg"/>
+          </p:nvPr>
+        </p:nvSpPr>
+        <p:spPr/>
+      </p:sp>
+      <p:sp>
+        <p:nvSpPr>
+          <p:cNvPr id="3" name="Notes Placeholder 2"/>
+          <p:cNvSpPr>
+            <a:spLocks noGrp="1"/>
+          </p:cNvSpPr>
+          <p:nvPr>
+            <p:ph type="body" idx="1"/>
+          </p:nvPr>
+        </p:nvSpPr>
+        <p:spPr/>
+        <p:txBody>
+          <a:bodyPr/>
+          <a:lstStyle/>
+          <a:p>
+            <a:r>
+              <a:rPr lang="en-US" dirty="0"/>
+              <a:t>I record this information in the official logbook of the class after the lesson.</a:t>
+            </a:r>
+            <a:endParaRPr lang="en-US" dirty="0"/>
+          </a:p>
+        </p:txBody>
+      </p:sp>
+      <p:sp>
+        <p:nvSpPr>
+          <p:cNvPr id="4" name="Slide Number Placeholder 3"/>
+          <p:cNvSpPr>
+            <a:spLocks noGrp="1"/>
+          </p:cNvSpPr>
+          <p:nvPr>
+            <p:ph type="sldNum" sz="quarter" idx="10"/>
+          </p:nvPr>
+        </p:nvSpPr>
+        <p:spPr/>
+        <p:txBody>
+          <a:bodyPr/>
+          <a:lstStyle/>
+          <a:p>
+            <a:fld id="{F7021451-1387-4CA6-816F-3879F97B5CBC}" type="slidenum">
+              <a:rPr lang="en-US"/>
+              <a:t>61</a:t>
+            </a:fld>
+            <a:endParaRPr lang="en-US"/>
+          </a:p>
+        </p:txBody>
+      </p:sp>
+    </p:spTree>
+    <p:extLst>
+      <p:ext uri="{BB962C8B-B14F-4D97-AF65-F5344CB8AC3E}">
+        <p14:creationId xmlns:p14="http://schemas.microsoft.com/office/powerpoint/2010/main" val="1024086991"/>
+      </p:ext>
+    </p:extLst>
+  </p:cSld>
+  <p:clrMapOvr>
+    <a:masterClrMapping/>
+  </p:clrMapOvr>
+</p:notes>
+</file>
+
+<file path=ppt/notesSlides/notesSlide62.xml><?xml version="1.0" encoding="utf-8"?>
+<p:notes xmlns:a="http://schemas.openxmlformats.org/drawingml/2006/main" xmlns:r="http://schemas.openxmlformats.org/officeDocument/2006/relationships" xmlns:p="http://schemas.openxmlformats.org/presentationml/2006/main">
+  <p:cSld>
+    <p:spTree>
+      <p:nvGrpSpPr>
+        <p:cNvPr id="1" name=""/>
+        <p:cNvGrpSpPr/>
+        <p:nvPr/>
+      </p:nvGrpSpPr>
+      <p:grpSpPr>
+        <a:xfrm>
+          <a:off x="0" y="0"/>
+          <a:ext cx="0" cy="0"/>
+          <a:chOff x="0" y="0"/>
+          <a:chExt cx="0" cy="0"/>
+        </a:xfrm>
+      </p:grpSpPr>
+      <p:sp>
+        <p:nvSpPr>
+          <p:cNvPr id="2" name="Slide Image Placeholder 1"/>
+          <p:cNvSpPr>
+            <a:spLocks noGrp="1" noRot="1" noChangeAspect="1"/>
+          </p:cNvSpPr>
+          <p:nvPr>
+            <p:ph type="sldImg"/>
+          </p:nvPr>
+        </p:nvSpPr>
+        <p:spPr/>
+      </p:sp>
+      <p:sp>
+        <p:nvSpPr>
+          <p:cNvPr id="3" name="Notes Placeholder 2"/>
+          <p:cNvSpPr>
+            <a:spLocks noGrp="1"/>
+          </p:cNvSpPr>
+          <p:nvPr>
+            <p:ph type="body" idx="1"/>
+          </p:nvPr>
+        </p:nvSpPr>
+        <p:spPr/>
+        <p:txBody>
+          <a:bodyPr/>
+          <a:lstStyle/>
+          <a:p>
+            <a:r>
+              <a:rPr lang="en-US" dirty="0"/>
+              <a:t>I complete the second page of the logbook: the matter taught, the evaluation, the homework and the attendance.</a:t>
+            </a:r>
+            <a:endParaRPr lang="en-US" dirty="0"/>
+          </a:p>
+        </p:txBody>
+      </p:sp>
+      <p:sp>
+        <p:nvSpPr>
+          <p:cNvPr id="4" name="Slide Number Placeholder 3"/>
+          <p:cNvSpPr>
+            <a:spLocks noGrp="1"/>
+          </p:cNvSpPr>
+          <p:nvPr>
+            <p:ph type="sldNum" sz="quarter" idx="10"/>
+          </p:nvPr>
+        </p:nvSpPr>
+        <p:spPr/>
+        <p:txBody>
+          <a:bodyPr/>
+          <a:lstStyle/>
+          <a:p>
+            <a:fld id="{F7021451-1387-4CA6-816F-3879F97B5CBC}" type="slidenum">
+              <a:rPr lang="en-US"/>
+              <a:t>62</a:t>
+            </a:fld>
+            <a:endParaRPr lang="en-US"/>
+          </a:p>
+        </p:txBody>
+      </p:sp>
+    </p:spTree>
+    <p:extLst>
+      <p:ext uri="{BB962C8B-B14F-4D97-AF65-F5344CB8AC3E}">
+        <p14:creationId xmlns:p14="http://schemas.microsoft.com/office/powerpoint/2010/main" val="1024086991"/>
+      </p:ext>
+    </p:extLst>
+  </p:cSld>
+  <p:clrMapOvr>
+    <a:masterClrMapping/>
+  </p:clrMapOvr>
+</p:notes>
+</file>
+
+<file path=ppt/notesSlides/notesSlide63.xml><?xml version="1.0" encoding="utf-8"?>
+<p:notes xmlns:a="http://schemas.openxmlformats.org/drawingml/2006/main" xmlns:r="http://schemas.openxmlformats.org/officeDocument/2006/relationships" xmlns:p="http://schemas.openxmlformats.org/presentationml/2006/main">
+  <p:cSld>
+    <p:spTree>
+      <p:nvGrpSpPr>
+        <p:cNvPr id="1" name=""/>
+        <p:cNvGrpSpPr/>
+        <p:nvPr/>
+      </p:nvGrpSpPr>
+      <p:grpSpPr>
+        <a:xfrm>
+          <a:off x="0" y="0"/>
+          <a:ext cx="0" cy="0"/>
+          <a:chOff x="0" y="0"/>
+          <a:chExt cx="0" cy="0"/>
+        </a:xfrm>
+      </p:grpSpPr>
+      <p:sp>
+        <p:nvSpPr>
+          <p:cNvPr id="2" name="Slide Image Placeholder 1"/>
+          <p:cNvSpPr>
+            <a:spLocks noGrp="1" noRot="1" noChangeAspect="1"/>
+          </p:cNvSpPr>
+          <p:nvPr>
+            <p:ph type="sldImg"/>
+          </p:nvPr>
+        </p:nvSpPr>
+        <p:spPr/>
+      </p:sp>
+      <p:sp>
+        <p:nvSpPr>
+          <p:cNvPr id="3" name="Notes Placeholder 2"/>
+          <p:cNvSpPr>
+            <a:spLocks noGrp="1"/>
+          </p:cNvSpPr>
+          <p:nvPr>
+            <p:ph type="body" idx="1"/>
+          </p:nvPr>
+        </p:nvSpPr>
+        <p:spPr/>
+        <p:txBody>
+          <a:bodyPr/>
+          <a:lstStyle/>
+          <a:p>
+            <a:r>
+              <a:rPr lang="en-US" dirty="0"/>
+              <a:t>This slide is for me, the teacher: it gives the timing of the lesson and what to do if the projector is not available.</a:t>
+            </a:r>
+            <a:endParaRPr lang="en-US" dirty="0"/>
+          </a:p>
+        </p:txBody>
+      </p:sp>
+      <p:sp>
+        <p:nvSpPr>
+          <p:cNvPr id="4" name="Slide Number Placeholder 3"/>
+          <p:cNvSpPr>
+            <a:spLocks noGrp="1"/>
+          </p:cNvSpPr>
+          <p:nvPr>
+            <p:ph type="sldNum" sz="quarter" idx="10"/>
+          </p:nvPr>
+        </p:nvSpPr>
+        <p:spPr/>
+        <p:txBody>
+          <a:bodyPr/>
+          <a:lstStyle/>
+          <a:p>
+            <a:fld id="{F7021451-1387-4CA6-816F-3879F97B5CBC}" type="slidenum">
+              <a:rPr lang="en-US"/>
+              <a:t>63</a:t>
+            </a:fld>
+            <a:endParaRPr lang="en-US"/>
+          </a:p>
+        </p:txBody>
+      </p:sp>
+    </p:spTree>
+    <p:extLst>
+      <p:ext uri="{BB962C8B-B14F-4D97-AF65-F5344CB8AC3E}">
+        <p14:creationId xmlns:p14="http://schemas.microsoft.com/office/powerpoint/2010/main" val="1024086991"/>
+      </p:ext>
+    </p:extLst>
+  </p:cSld>
+  <p:clrMapOvr>
+    <a:masterClrMapping/>
+  </p:clrMapOvr>
+</p:notes>
+</file>
+
+<file path=ppt/notesSlides/notesSlide64.xml><?xml version="1.0" encoding="utf-8"?>
+<p:notes xmlns:a="http://schemas.openxmlformats.org/drawingml/2006/main" xmlns:r="http://schemas.openxmlformats.org/officeDocument/2006/relationships" xmlns:p="http://schemas.openxmlformats.org/presentationml/2006/main">
+  <p:cSld>
+    <p:spTree>
+      <p:nvGrpSpPr>
+        <p:cNvPr id="1" name=""/>
+        <p:cNvGrpSpPr/>
+        <p:nvPr/>
+      </p:nvGrpSpPr>
+      <p:grpSpPr>
+        <a:xfrm>
+          <a:off x="0" y="0"/>
+          <a:ext cx="0" cy="0"/>
+          <a:chOff x="0" y="0"/>
+          <a:chExt cx="0" cy="0"/>
+        </a:xfrm>
+      </p:grpSpPr>
+      <p:sp>
+        <p:nvSpPr>
+          <p:cNvPr id="2" name="Slide Image Placeholder 1"/>
+          <p:cNvSpPr>
+            <a:spLocks noGrp="1" noRot="1" noChangeAspect="1"/>
+          </p:cNvSpPr>
+          <p:nvPr>
+            <p:ph type="sldImg"/>
+          </p:nvPr>
+        </p:nvSpPr>
+        <p:spPr/>
+      </p:sp>
+      <p:sp>
+        <p:nvSpPr>
+          <p:cNvPr id="3" name="Notes Placeholder 2"/>
+          <p:cNvSpPr>
+            <a:spLocks noGrp="1"/>
+          </p:cNvSpPr>
+          <p:nvPr>
+            <p:ph type="body" idx="1"/>
+          </p:nvPr>
+        </p:nvSpPr>
+        <p:spPr/>
+        <p:txBody>
+          <a:bodyPr/>
+          <a:lstStyle/>
+          <a:p>
+            <a:r>
+              <a:rPr lang="en-US" dirty="0"/>
+              <a:t>These are the references and picture credits used to prepare this lesson.</a:t>
+            </a:r>
+            <a:endParaRPr lang="en-US" dirty="0"/>
+          </a:p>
+        </p:txBody>
+      </p:sp>
+      <p:sp>
+        <p:nvSpPr>
+          <p:cNvPr id="4" name="Slide Number Placeholder 3"/>
+          <p:cNvSpPr>
+            <a:spLocks noGrp="1"/>
+          </p:cNvSpPr>
+          <p:nvPr>
+            <p:ph type="sldNum" sz="quarter" idx="10"/>
+          </p:nvPr>
+        </p:nvSpPr>
+        <p:spPr/>
+        <p:txBody>
+          <a:bodyPr/>
+          <a:lstStyle/>
+          <a:p>
+            <a:fld id="{F7021451-1387-4CA6-816F-3879F97B5CBC}" type="slidenum">
+              <a:rPr lang="en-US"/>
+              <a:t>64</a:t>
             </a:fld>
             <a:endParaRPr lang="en-US"/>
           </a:p>
@@ -14806,7 +15162,7 @@
                 <a:ea typeface="Times New Roman" pitchFamily="34" charset="-122"/>
                 <a:cs typeface="Times New Roman" pitchFamily="34" charset="-120"/>
               </a:rPr>
-              <a:t>Urban heat island: </a:t>
+              <a:t>Meso-climate: </a:t>
             </a:r>
             <a:pPr algn="l" indent="0" marL="0">
               <a:spcAft>
@@ -14823,7 +15179,7 @@
                 <a:ea typeface="Times New Roman" pitchFamily="34" charset="-122"/>
                 <a:cs typeface="Times New Roman" pitchFamily="34" charset="-120"/>
               </a:rPr>
-              <a:t>It is the higher temperature of a town compared with the surrounding countryside.</a:t>
+              <a:t>It is the climate of a medium-sized area, such as a town, a valley or a lake shore, a few kilometres to tens of kilometres wide.</a:t>
             </a:r>
             <a:endParaRPr lang="en-US" sz="4000" dirty="0"/>
           </a:p>
@@ -14843,7 +15199,7 @@
                 <a:ea typeface="Times New Roman" pitchFamily="34" charset="-122"/>
                 <a:cs typeface="Times New Roman" pitchFamily="34" charset="-120"/>
               </a:rPr>
-              <a:t>Anthropogenic heat: </a:t>
+              <a:t>Heat island: </a:t>
             </a:r>
             <a:pPr algn="l" indent="0" marL="0">
               <a:spcAft>
@@ -14860,7 +15216,7 @@
                 <a:ea typeface="Times New Roman" pitchFamily="34" charset="-122"/>
                 <a:cs typeface="Times New Roman" pitchFamily="34" charset="-120"/>
               </a:rPr>
-              <a:t>It is the heat released by human activities (vehicles, machines, air conditioners).</a:t>
+              <a:t>It is the higher temperature of a town compared with the surrounding countryside.</a:t>
             </a:r>
             <a:endParaRPr lang="en-US" sz="4000" dirty="0"/>
           </a:p>
@@ -15079,7 +15435,7 @@
                 <a:ea typeface="Times New Roman" pitchFamily="34" charset="-122"/>
                 <a:cs typeface="Times New Roman" pitchFamily="34" charset="-120"/>
               </a:rPr>
-              <a:t>Evapotranspiration: </a:t>
+              <a:t>Anthropogenic heat: </a:t>
             </a:r>
             <a:pPr algn="l" indent="0" marL="0">
               <a:spcAft>
@@ -15096,7 +15452,7 @@
                 <a:ea typeface="Times New Roman" pitchFamily="34" charset="-122"/>
                 <a:cs typeface="Times New Roman" pitchFamily="34" charset="-120"/>
               </a:rPr>
-              <a:t>It is the combined loss of water by evaporation and by plant transpiration.</a:t>
+              <a:t>It is the heat released by human activities (vehicles, machines, air conditioners).</a:t>
             </a:r>
             <a:endParaRPr lang="en-US" sz="4000" dirty="0"/>
           </a:p>
@@ -15249,7 +15605,7 @@
                 <a:ea typeface="Times New Roman" pitchFamily="34" charset="-122"/>
                 <a:cs typeface="Times New Roman" pitchFamily="34" charset="-120"/>
               </a:rPr>
-              <a:t>1. Meaning and Classification of Micro-climates</a:t>
+              <a:t>1. Meaning of Micro-climates</a:t>
             </a:r>
             <a:endParaRPr lang="en-US" sz="3600" dirty="0"/>
           </a:p>
@@ -15264,7 +15620,7 @@
         <p:spPr>
           <a:xfrm>
             <a:off x="365760" y="1783080"/>
-            <a:ext cx="4846320" cy="4617720"/>
+            <a:ext cx="6035040" cy="4617720"/>
           </a:xfrm>
           <a:prstGeom prst="rect">
             <a:avLst/>
@@ -15283,7 +15639,7 @@
               <a:buNone/>
             </a:pPr>
             <a:r>
-              <a:rPr lang="en-US" sz="3600" i="1" dirty="0">
+              <a:rPr lang="en-US" sz="2800" i="1" dirty="0">
                 <a:solidFill>
                   <a:srgbClr val="111111"/>
                 </a:solidFill>
@@ -15291,9 +15647,9 @@
                 <a:ea typeface="Times New Roman" pitchFamily="34" charset="-122"/>
                 <a:cs typeface="Times New Roman" pitchFamily="34" charset="-120"/>
               </a:rPr>
-              <a:t>Micro-climates are classified as follows:</a:t>
-            </a:r>
-            <a:endParaRPr lang="en-US" sz="3600" dirty="0"/>
+              <a:t>Micro-climates are explained as follows:</a:t>
+            </a:r>
+            <a:endParaRPr lang="en-US" sz="2800" dirty="0"/>
           </a:p>
           <a:p>
             <a:pPr algn="l" indent="0" marL="0">
@@ -15303,7 +15659,7 @@
               <a:buNone/>
             </a:pPr>
             <a:r>
-              <a:rPr lang="en-US" sz="3600" b="1" dirty="0">
+              <a:rPr lang="en-US" sz="2800" b="1" dirty="0">
                 <a:solidFill>
                   <a:srgbClr val="111111"/>
                 </a:solidFill>
@@ -15311,7 +15667,7 @@
                 <a:ea typeface="Times New Roman" pitchFamily="34" charset="-122"/>
                 <a:cs typeface="Times New Roman" pitchFamily="34" charset="-120"/>
               </a:rPr>
-              <a:t>Urban climate: </a:t>
+              <a:t>Micro-climate: </a:t>
             </a:r>
             <a:pPr algn="l" indent="0" marL="0">
               <a:spcAft>
@@ -15320,7 +15676,7 @@
               <a:buNone/>
             </a:pPr>
             <a:r>
-              <a:rPr lang="en-US" sz="3600" dirty="0">
+              <a:rPr lang="en-US" sz="2800" dirty="0">
                 <a:solidFill>
                   <a:srgbClr val="111111"/>
                 </a:solidFill>
@@ -15328,9 +15684,9 @@
                 <a:ea typeface="Times New Roman" pitchFamily="34" charset="-122"/>
                 <a:cs typeface="Times New Roman" pitchFamily="34" charset="-120"/>
               </a:rPr>
-              <a:t>The climate of a town, warmer, drier and more polluted than the countryside.</a:t>
-            </a:r>
-            <a:endParaRPr lang="en-US" sz="3600" dirty="0"/>
+              <a:t>A micro-climate is the special climate of a small area, from a few metres to a few kilometres, such as a garden, a forest clearing or a street. It differs from the regional climate because of local surfaces, relief, water or vegetation.</a:t>
+            </a:r>
+            <a:endParaRPr lang="en-US" sz="2800" dirty="0"/>
           </a:p>
         </p:txBody>
       </p:sp>
@@ -15350,8 +15706,8 @@
         </p:blipFill>
         <p:spPr>
           <a:xfrm>
-            <a:off x="5349240" y="2617506"/>
-            <a:ext cx="6659575" cy="2601397"/>
+            <a:off x="6537960" y="2849678"/>
+            <a:ext cx="5470855" cy="2137053"/>
           </a:xfrm>
           <a:prstGeom prst="rect">
             <a:avLst/>
@@ -15366,8 +15722,8 @@
         </p:nvSpPr>
         <p:spPr>
           <a:xfrm>
-            <a:off x="5349240" y="6089904"/>
-            <a:ext cx="6659575" cy="347472"/>
+            <a:off x="6537960" y="6089904"/>
+            <a:ext cx="5470855" cy="347472"/>
           </a:xfrm>
           <a:prstGeom prst="rect">
             <a:avLst/>
@@ -15765,7 +16121,7 @@
         <p:spPr>
           <a:xfrm>
             <a:off x="0" y="658368"/>
-            <a:ext cx="5120640" cy="5833872"/>
+            <a:ext cx="2468880" cy="5833872"/>
           </a:xfrm>
           <a:prstGeom prst="rect">
             <a:avLst/>
@@ -15780,8 +16136,8 @@
         </p:nvSpPr>
         <p:spPr>
           <a:xfrm>
-            <a:off x="5349240" y="1005840"/>
-            <a:ext cx="6522415" cy="731520"/>
+            <a:off x="2697480" y="1005840"/>
+            <a:ext cx="9174175" cy="731520"/>
           </a:xfrm>
           <a:prstGeom prst="rect">
             <a:avLst/>
@@ -15807,7 +16163,7 @@
                 <a:ea typeface="Times New Roman" pitchFamily="34" charset="-122"/>
                 <a:cs typeface="Times New Roman" pitchFamily="34" charset="-120"/>
               </a:rPr>
-              <a:t>1. Meaning and Classification of Micro-climates</a:t>
+              <a:t>1. Meaning of Micro-climates</a:t>
             </a:r>
             <a:endParaRPr lang="en-US" sz="3600" dirty="0"/>
           </a:p>
@@ -15821,8 +16177,8 @@
         </p:nvSpPr>
         <p:spPr>
           <a:xfrm>
-            <a:off x="5349240" y="1783080"/>
-            <a:ext cx="6522415" cy="4663440"/>
+            <a:off x="2697480" y="1783080"/>
+            <a:ext cx="9174175" cy="4663440"/>
           </a:xfrm>
           <a:prstGeom prst="rect">
             <a:avLst/>
@@ -15849,7 +16205,7 @@
                 <a:ea typeface="Times New Roman" pitchFamily="34" charset="-122"/>
                 <a:cs typeface="Times New Roman" pitchFamily="34" charset="-120"/>
               </a:rPr>
-              <a:t>Mountain climate: </a:t>
+              <a:t>Micro- and meso-climates: </a:t>
             </a:r>
             <a:pPr algn="l" indent="0" marL="0">
               <a:spcAft>
@@ -15866,7 +16222,7 @@
                 <a:ea typeface="Times New Roman" pitchFamily="34" charset="-122"/>
                 <a:cs typeface="Times New Roman" pitchFamily="34" charset="-120"/>
               </a:rPr>
-              <a:t>Conditions vary with altitude and with the side of the mountain.</a:t>
+              <a:t>The climate of a larger area, such as a whole town or a valley, is called a meso-climate. In practice, both are studied together as local climates, different from the macro-climate of a region.</a:t>
             </a:r>
             <a:endParaRPr lang="en-US" sz="4000" dirty="0"/>
           </a:p>
@@ -16019,7 +16375,7 @@
                 <a:ea typeface="Times New Roman" pitchFamily="34" charset="-122"/>
                 <a:cs typeface="Times New Roman" pitchFamily="34" charset="-120"/>
               </a:rPr>
-              <a:t>1. Meaning and Classification of Micro-climates</a:t>
+              <a:t>2. Classification of Micro-climates</a:t>
             </a:r>
             <a:endParaRPr lang="en-US" sz="3600" dirty="0"/>
           </a:p>
@@ -16034,7 +16390,7 @@
         <p:spPr>
           <a:xfrm>
             <a:off x="365760" y="1783080"/>
-            <a:ext cx="4846320" cy="4617720"/>
+            <a:ext cx="6035040" cy="4617720"/>
           </a:xfrm>
           <a:prstGeom prst="rect">
             <a:avLst/>
@@ -16053,7 +16409,7 @@
               <a:buNone/>
             </a:pPr>
             <a:r>
-              <a:rPr lang="en-US" sz="3600" b="1" dirty="0">
+              <a:rPr lang="en-US" sz="3400" i="1" dirty="0">
                 <a:solidFill>
                   <a:srgbClr val="111111"/>
                 </a:solidFill>
@@ -16061,8 +16417,11 @@
                 <a:ea typeface="Times New Roman" pitchFamily="34" charset="-122"/>
                 <a:cs typeface="Times New Roman" pitchFamily="34" charset="-120"/>
               </a:rPr>
-              <a:t>Lakeside climate: </a:t>
-            </a:r>
+              <a:t>Micro-climates are classified into the following types:</a:t>
+            </a:r>
+            <a:endParaRPr lang="en-US" sz="3400" dirty="0"/>
+          </a:p>
+          <a:p>
             <a:pPr algn="l" indent="0" marL="0">
               <a:spcAft>
                 <a:spcPts val="800"/>
@@ -16070,7 +16429,7 @@
               <a:buNone/>
             </a:pPr>
             <a:r>
-              <a:rPr lang="en-US" sz="3600" dirty="0">
+              <a:rPr lang="en-US" sz="3400" b="1" dirty="0">
                 <a:solidFill>
                   <a:srgbClr val="111111"/>
                 </a:solidFill>
@@ -16078,15 +16437,32 @@
                 <a:ea typeface="Times New Roman" pitchFamily="34" charset="-122"/>
                 <a:cs typeface="Times New Roman" pitchFamily="34" charset="-120"/>
               </a:rPr>
-              <a:t>Along a large lake such as Lake Lagdo, the air is cooler and more humid.</a:t>
-            </a:r>
-            <a:endParaRPr lang="en-US" sz="3600" dirty="0"/>
+              <a:t>Urban climate: </a:t>
+            </a:r>
+            <a:pPr algn="l" indent="0" marL="0">
+              <a:spcAft>
+                <a:spcPts val="800"/>
+              </a:spcAft>
+              <a:buNone/>
+            </a:pPr>
+            <a:r>
+              <a:rPr lang="en-US" sz="3400" dirty="0">
+                <a:solidFill>
+                  <a:srgbClr val="111111"/>
+                </a:solidFill>
+                <a:latin typeface="Times New Roman" pitchFamily="34" charset="0"/>
+                <a:ea typeface="Times New Roman" pitchFamily="34" charset="-122"/>
+                <a:cs typeface="Times New Roman" pitchFamily="34" charset="-120"/>
+              </a:rPr>
+              <a:t>The climate of a town is warmer, drier and more polluted than that of the surrounding countryside. It is created by buildings, roads, vehicles and industries.</a:t>
+            </a:r>
+            <a:endParaRPr lang="en-US" sz="3400" dirty="0"/>
           </a:p>
         </p:txBody>
       </p:sp>
       <p:pic>
         <p:nvPicPr>
-          <p:cNvPr id="5" name="Image 0" descr="/home/claude/f4/img/v2/lsa_lake.jpg">    </p:cNvPr>
+          <p:cNvPr id="5" name="Image 0" descr="/home/claude/f4/img/v2/lsa_douala.jpg">    </p:cNvPr>
           <p:cNvPicPr>
             <a:picLocks noChangeAspect="1"/>
           </p:cNvPicPr>
@@ -16100,8 +16476,8 @@
         </p:blipFill>
         <p:spPr>
           <a:xfrm>
-            <a:off x="5349240" y="2071212"/>
-            <a:ext cx="6659575" cy="3693983"/>
+            <a:off x="6537960" y="2400897"/>
+            <a:ext cx="5470855" cy="3034615"/>
           </a:xfrm>
           <a:prstGeom prst="rect">
             <a:avLst/>
@@ -16116,8 +16492,8 @@
         </p:nvSpPr>
         <p:spPr>
           <a:xfrm>
-            <a:off x="5349240" y="6089904"/>
-            <a:ext cx="6659575" cy="347472"/>
+            <a:off x="6537960" y="6089904"/>
+            <a:ext cx="5470855" cy="347472"/>
           </a:xfrm>
           <a:prstGeom prst="rect">
             <a:avLst/>
@@ -16141,7 +16517,7 @@
                 <a:ea typeface="Times New Roman" pitchFamily="34" charset="-122"/>
                 <a:cs typeface="Times New Roman" pitchFamily="34" charset="-120"/>
               </a:rPr>
-              <a:t>Illustration: a lakeside</a:t>
+              <a:t>Illustration: Douala</a:t>
             </a:r>
             <a:endParaRPr lang="en-US" sz="1600" dirty="0"/>
           </a:p>
@@ -16259,109 +16635,9 @@
           </a:p>
         </p:txBody>
       </p:sp>
-      <p:sp>
-        <p:nvSpPr>
-          <p:cNvPr id="3" name="Text 1"/>
-          <p:cNvSpPr/>
-          <p:nvPr/>
-        </p:nvSpPr>
-        <p:spPr>
-          <a:xfrm>
-            <a:off x="365760" y="1005840"/>
-            <a:ext cx="11460175" cy="731520"/>
-          </a:xfrm>
-          <a:prstGeom prst="rect">
-            <a:avLst/>
-          </a:prstGeom>
-          <a:noFill/>
-          <a:ln/>
-        </p:spPr>
-        <p:txBody>
-          <a:bodyPr wrap="square" lIns="0" tIns="0" rIns="0" bIns="0" rtlCol="0" anchor="ctr">
-            <a:normAutofit/>
-          </a:bodyPr>
-          <a:lstStyle/>
-          <a:p>
-            <a:pPr algn="ctr" indent="0" marL="0">
-              <a:buNone/>
-            </a:pPr>
-            <a:r>
-              <a:rPr lang="en-US" sz="3600" b="1" dirty="0">
-                <a:solidFill>
-                  <a:srgbClr val="990011"/>
-                </a:solidFill>
-                <a:latin typeface="Times New Roman" pitchFamily="34" charset="0"/>
-                <a:ea typeface="Times New Roman" pitchFamily="34" charset="-122"/>
-                <a:cs typeface="Times New Roman" pitchFamily="34" charset="-120"/>
-              </a:rPr>
-              <a:t>1. Meaning and Classification of Micro-climates</a:t>
-            </a:r>
-            <a:endParaRPr lang="en-US" sz="3600" dirty="0"/>
-          </a:p>
-        </p:txBody>
-      </p:sp>
-      <p:sp>
-        <p:nvSpPr>
-          <p:cNvPr id="4" name="Text 2"/>
-          <p:cNvSpPr/>
-          <p:nvPr/>
-        </p:nvSpPr>
-        <p:spPr>
-          <a:xfrm>
-            <a:off x="365760" y="1783080"/>
-            <a:ext cx="4846320" cy="4617720"/>
-          </a:xfrm>
-          <a:prstGeom prst="rect">
-            <a:avLst/>
-          </a:prstGeom>
-          <a:noFill/>
-          <a:ln/>
-        </p:spPr>
-        <p:txBody>
-          <a:bodyPr wrap="square" lIns="0" tIns="0" rIns="0" bIns="0" rtlCol="0" anchor="t"/>
-          <a:lstStyle/>
-          <a:p>
-            <a:pPr algn="l" indent="0" marL="0">
-              <a:spcAft>
-                <a:spcPts val="800"/>
-              </a:spcAft>
-              <a:buNone/>
-            </a:pPr>
-            <a:r>
-              <a:rPr lang="en-US" sz="3600" b="1" dirty="0">
-                <a:solidFill>
-                  <a:srgbClr val="111111"/>
-                </a:solidFill>
-                <a:latin typeface="Times New Roman" pitchFamily="34" charset="0"/>
-                <a:ea typeface="Times New Roman" pitchFamily="34" charset="-122"/>
-                <a:cs typeface="Times New Roman" pitchFamily="34" charset="-120"/>
-              </a:rPr>
-              <a:t>Forest climate: </a:t>
-            </a:r>
-            <a:pPr algn="l" indent="0" marL="0">
-              <a:spcAft>
-                <a:spcPts val="800"/>
-              </a:spcAft>
-              <a:buNone/>
-            </a:pPr>
-            <a:r>
-              <a:rPr lang="en-US" sz="3600" dirty="0">
-                <a:solidFill>
-                  <a:srgbClr val="111111"/>
-                </a:solidFill>
-                <a:latin typeface="Times New Roman" pitchFamily="34" charset="0"/>
-                <a:ea typeface="Times New Roman" pitchFamily="34" charset="-122"/>
-                <a:cs typeface="Times New Roman" pitchFamily="34" charset="-120"/>
-              </a:rPr>
-              <a:t>Inside a forest, the air is shady, cool, humid and calm.</a:t>
-            </a:r>
-            <a:endParaRPr lang="en-US" sz="3600" dirty="0"/>
-          </a:p>
-        </p:txBody>
-      </p:sp>
       <p:pic>
         <p:nvPicPr>
-          <p:cNvPr id="5" name="Image 0" descr="/home/claude/f4/img/v2/f2t_rainforest.jpg">    </p:cNvPr>
+          <p:cNvPr id="3" name="Image 0" descr="/home/claude/f4/img/minesec_sheet.png">    </p:cNvPr>
           <p:cNvPicPr>
             <a:picLocks noChangeAspect="1"/>
           </p:cNvPicPr>
@@ -16375,8 +16651,8 @@
         </p:blipFill>
         <p:spPr>
           <a:xfrm>
-            <a:off x="5349240" y="2071212"/>
-            <a:ext cx="6659575" cy="3693983"/>
+            <a:off x="0" y="658368"/>
+            <a:ext cx="5120640" cy="5833872"/>
           </a:xfrm>
           <a:prstGeom prst="rect">
             <a:avLst/>
@@ -16385,14 +16661,14 @@
       </p:pic>
       <p:sp>
         <p:nvSpPr>
-          <p:cNvPr id="6" name="Text 3"/>
+          <p:cNvPr id="4" name="Text 1"/>
           <p:cNvSpPr/>
           <p:nvPr/>
         </p:nvSpPr>
         <p:spPr>
           <a:xfrm>
-            <a:off x="5349240" y="6089904"/>
-            <a:ext cx="6659575" cy="347472"/>
+            <a:off x="5349240" y="1005840"/>
+            <a:ext cx="6522415" cy="731520"/>
           </a:xfrm>
           <a:prstGeom prst="rect">
             <a:avLst/>
@@ -16401,24 +16677,85 @@
           <a:ln/>
         </p:spPr>
         <p:txBody>
-          <a:bodyPr wrap="square" lIns="0" tIns="0" rIns="0" bIns="0" rtlCol="0" anchor="ctr"/>
+          <a:bodyPr wrap="square" lIns="0" tIns="0" rIns="0" bIns="0" rtlCol="0" anchor="ctr">
+            <a:normAutofit/>
+          </a:bodyPr>
           <a:lstStyle/>
           <a:p>
             <a:pPr algn="ctr" indent="0" marL="0">
               <a:buNone/>
             </a:pPr>
             <a:r>
-              <a:rPr lang="en-US" sz="1600" i="1" dirty="0">
-                <a:solidFill>
-                  <a:srgbClr val="555555"/>
+              <a:rPr lang="en-US" sz="3600" b="1" dirty="0">
+                <a:solidFill>
+                  <a:srgbClr val="990011"/>
                 </a:solidFill>
                 <a:latin typeface="Times New Roman" pitchFamily="34" charset="0"/>
                 <a:ea typeface="Times New Roman" pitchFamily="34" charset="-122"/>
                 <a:cs typeface="Times New Roman" pitchFamily="34" charset="-120"/>
               </a:rPr>
-              <a:t>Illustration: a forest</a:t>
-            </a:r>
-            <a:endParaRPr lang="en-US" sz="1600" dirty="0"/>
+              <a:t>2. Classification of Micro-climates</a:t>
+            </a:r>
+            <a:endParaRPr lang="en-US" sz="3600" dirty="0"/>
+          </a:p>
+        </p:txBody>
+      </p:sp>
+      <p:sp>
+        <p:nvSpPr>
+          <p:cNvPr id="5" name="Text 2"/>
+          <p:cNvSpPr/>
+          <p:nvPr/>
+        </p:nvSpPr>
+        <p:spPr>
+          <a:xfrm>
+            <a:off x="5349240" y="1783080"/>
+            <a:ext cx="6522415" cy="4663440"/>
+          </a:xfrm>
+          <a:prstGeom prst="rect">
+            <a:avLst/>
+          </a:prstGeom>
+          <a:noFill/>
+          <a:ln/>
+        </p:spPr>
+        <p:txBody>
+          <a:bodyPr wrap="square" lIns="0" tIns="0" rIns="0" bIns="0" rtlCol="0" anchor="t"/>
+          <a:lstStyle/>
+          <a:p>
+            <a:pPr algn="l" indent="0" marL="0">
+              <a:spcAft>
+                <a:spcPts val="800"/>
+              </a:spcAft>
+              <a:buNone/>
+            </a:pPr>
+            <a:r>
+              <a:rPr lang="en-US" sz="4000" b="1" dirty="0">
+                <a:solidFill>
+                  <a:srgbClr val="111111"/>
+                </a:solidFill>
+                <a:latin typeface="Times New Roman" pitchFamily="34" charset="0"/>
+                <a:ea typeface="Times New Roman" pitchFamily="34" charset="-122"/>
+                <a:cs typeface="Times New Roman" pitchFamily="34" charset="-120"/>
+              </a:rPr>
+              <a:t>Mountain climate: </a:t>
+            </a:r>
+            <a:pPr algn="l" indent="0" marL="0">
+              <a:spcAft>
+                <a:spcPts val="800"/>
+              </a:spcAft>
+              <a:buNone/>
+            </a:pPr>
+            <a:r>
+              <a:rPr lang="en-US" sz="4000" dirty="0">
+                <a:solidFill>
+                  <a:srgbClr val="111111"/>
+                </a:solidFill>
+                <a:latin typeface="Times New Roman" pitchFamily="34" charset="0"/>
+                <a:ea typeface="Times New Roman" pitchFamily="34" charset="-122"/>
+                <a:cs typeface="Times New Roman" pitchFamily="34" charset="-120"/>
+              </a:rPr>
+              <a:t>On a mountain, temperature and rainfall change with altitude and with the side of the slope. Each level therefore has its own climate and vegetation.</a:t>
+            </a:r>
+            <a:endParaRPr lang="en-US" sz="4000" dirty="0"/>
           </a:p>
         </p:txBody>
       </p:sp>
@@ -16569,7 +16906,7 @@
                 <a:ea typeface="Times New Roman" pitchFamily="34" charset="-122"/>
                 <a:cs typeface="Times New Roman" pitchFamily="34" charset="-120"/>
               </a:rPr>
-              <a:t>2. Characteristics of Urban Climates</a:t>
+              <a:t>2. Classification of Micro-climates</a:t>
             </a:r>
             <a:endParaRPr lang="en-US" sz="3600" dirty="0"/>
           </a:p>
@@ -16584,7 +16921,7 @@
         <p:spPr>
           <a:xfrm>
             <a:off x="365760" y="1783080"/>
-            <a:ext cx="4846320" cy="4617720"/>
+            <a:ext cx="6035040" cy="4617720"/>
           </a:xfrm>
           <a:prstGeom prst="rect">
             <a:avLst/>
@@ -16603,7 +16940,7 @@
               <a:buNone/>
             </a:pPr>
             <a:r>
-              <a:rPr lang="en-US" sz="3200" i="1" dirty="0">
+              <a:rPr lang="en-US" sz="3600" b="1" dirty="0">
                 <a:solidFill>
                   <a:srgbClr val="111111"/>
                 </a:solidFill>
@@ -16611,11 +16948,8 @@
                 <a:ea typeface="Times New Roman" pitchFamily="34" charset="-122"/>
                 <a:cs typeface="Times New Roman" pitchFamily="34" charset="-120"/>
               </a:rPr>
-              <a:t>Compared with the countryside, towns have the following characteristics:</a:t>
-            </a:r>
-            <a:endParaRPr lang="en-US" sz="3200" dirty="0"/>
-          </a:p>
-          <a:p>
+              <a:t>Lakeside climate: </a:t>
+            </a:r>
             <a:pPr algn="l" indent="0" marL="0">
               <a:spcAft>
                 <a:spcPts val="800"/>
@@ -16623,7 +16957,7 @@
               <a:buNone/>
             </a:pPr>
             <a:r>
-              <a:rPr lang="en-US" sz="3200" b="1" dirty="0">
+              <a:rPr lang="en-US" sz="3600" dirty="0">
                 <a:solidFill>
                   <a:srgbClr val="111111"/>
                 </a:solidFill>
@@ -16631,32 +16965,15 @@
                 <a:ea typeface="Times New Roman" pitchFamily="34" charset="-122"/>
                 <a:cs typeface="Times New Roman" pitchFamily="34" charset="-120"/>
               </a:rPr>
-              <a:t>Higher temperatures: </a:t>
-            </a:r>
-            <a:pPr algn="l" indent="0" marL="0">
-              <a:spcAft>
-                <a:spcPts val="800"/>
-              </a:spcAft>
-              <a:buNone/>
-            </a:pPr>
-            <a:r>
-              <a:rPr lang="en-US" sz="3200" dirty="0">
-                <a:solidFill>
-                  <a:srgbClr val="111111"/>
-                </a:solidFill>
-                <a:latin typeface="Times New Roman" pitchFamily="34" charset="0"/>
-                <a:ea typeface="Times New Roman" pitchFamily="34" charset="-122"/>
-                <a:cs typeface="Times New Roman" pitchFamily="34" charset="-120"/>
-              </a:rPr>
-              <a:t>Towns are warmer, especially at night: this is the urban heat island.</a:t>
-            </a:r>
-            <a:endParaRPr lang="en-US" sz="3200" dirty="0"/>
+              <a:t>Along a large lake, such as Lake Lagdo or Lake Chad, the water keeps the air cooler by day and more humid. Lake breezes blow onto the shore in the afternoon.</a:t>
+            </a:r>
+            <a:endParaRPr lang="en-US" sz="3600" dirty="0"/>
           </a:p>
         </p:txBody>
       </p:sp>
       <p:pic>
         <p:nvPicPr>
-          <p:cNvPr id="5" name="Image 0" descr="/home/claude/f4/img/v2/heat_island_big.png">    </p:cNvPr>
+          <p:cNvPr id="5" name="Image 0" descr="/home/claude/f4/img/v2/lsa_lake.jpg">    </p:cNvPr>
           <p:cNvPicPr>
             <a:picLocks noChangeAspect="1"/>
           </p:cNvPicPr>
@@ -16670,8 +16987,8 @@
         </p:blipFill>
         <p:spPr>
           <a:xfrm>
-            <a:off x="5349240" y="2617506"/>
-            <a:ext cx="6659575" cy="2601397"/>
+            <a:off x="6537960" y="2400897"/>
+            <a:ext cx="5470855" cy="3034615"/>
           </a:xfrm>
           <a:prstGeom prst="rect">
             <a:avLst/>
@@ -16686,8 +17003,8 @@
         </p:nvSpPr>
         <p:spPr>
           <a:xfrm>
-            <a:off x="5349240" y="6089904"/>
-            <a:ext cx="6659575" cy="347472"/>
+            <a:off x="6537960" y="6089904"/>
+            <a:ext cx="5470855" cy="347472"/>
           </a:xfrm>
           <a:prstGeom prst="rect">
             <a:avLst/>
@@ -16711,7 +17028,7 @@
                 <a:ea typeface="Times New Roman" pitchFamily="34" charset="-122"/>
                 <a:cs typeface="Times New Roman" pitchFamily="34" charset="-120"/>
               </a:rPr>
-              <a:t>Illustration: the urban heat island</a:t>
+              <a:t>Illustration: a lake shore</a:t>
             </a:r>
             <a:endParaRPr lang="en-US" sz="1600" dirty="0"/>
           </a:p>
@@ -16829,9 +17146,109 @@
           </a:p>
         </p:txBody>
       </p:sp>
+      <p:sp>
+        <p:nvSpPr>
+          <p:cNvPr id="3" name="Text 1"/>
+          <p:cNvSpPr/>
+          <p:nvPr/>
+        </p:nvSpPr>
+        <p:spPr>
+          <a:xfrm>
+            <a:off x="365760" y="1005840"/>
+            <a:ext cx="11460175" cy="731520"/>
+          </a:xfrm>
+          <a:prstGeom prst="rect">
+            <a:avLst/>
+          </a:prstGeom>
+          <a:noFill/>
+          <a:ln/>
+        </p:spPr>
+        <p:txBody>
+          <a:bodyPr wrap="square" lIns="0" tIns="0" rIns="0" bIns="0" rtlCol="0" anchor="ctr">
+            <a:normAutofit/>
+          </a:bodyPr>
+          <a:lstStyle/>
+          <a:p>
+            <a:pPr algn="ctr" indent="0" marL="0">
+              <a:buNone/>
+            </a:pPr>
+            <a:r>
+              <a:rPr lang="en-US" sz="3600" b="1" dirty="0">
+                <a:solidFill>
+                  <a:srgbClr val="990011"/>
+                </a:solidFill>
+                <a:latin typeface="Times New Roman" pitchFamily="34" charset="0"/>
+                <a:ea typeface="Times New Roman" pitchFamily="34" charset="-122"/>
+                <a:cs typeface="Times New Roman" pitchFamily="34" charset="-120"/>
+              </a:rPr>
+              <a:t>2. Classification of Micro-climates</a:t>
+            </a:r>
+            <a:endParaRPr lang="en-US" sz="3600" dirty="0"/>
+          </a:p>
+        </p:txBody>
+      </p:sp>
+      <p:sp>
+        <p:nvSpPr>
+          <p:cNvPr id="4" name="Text 2"/>
+          <p:cNvSpPr/>
+          <p:nvPr/>
+        </p:nvSpPr>
+        <p:spPr>
+          <a:xfrm>
+            <a:off x="365760" y="1783080"/>
+            <a:ext cx="6035040" cy="4617720"/>
+          </a:xfrm>
+          <a:prstGeom prst="rect">
+            <a:avLst/>
+          </a:prstGeom>
+          <a:noFill/>
+          <a:ln/>
+        </p:spPr>
+        <p:txBody>
+          <a:bodyPr wrap="square" lIns="0" tIns="0" rIns="0" bIns="0" rtlCol="0" anchor="t"/>
+          <a:lstStyle/>
+          <a:p>
+            <a:pPr algn="l" indent="0" marL="0">
+              <a:spcAft>
+                <a:spcPts val="800"/>
+              </a:spcAft>
+              <a:buNone/>
+            </a:pPr>
+            <a:r>
+              <a:rPr lang="en-US" sz="3600" b="1" dirty="0">
+                <a:solidFill>
+                  <a:srgbClr val="111111"/>
+                </a:solidFill>
+                <a:latin typeface="Times New Roman" pitchFamily="34" charset="0"/>
+                <a:ea typeface="Times New Roman" pitchFamily="34" charset="-122"/>
+                <a:cs typeface="Times New Roman" pitchFamily="34" charset="-120"/>
+              </a:rPr>
+              <a:t>Forest climate: </a:t>
+            </a:r>
+            <a:pPr algn="l" indent="0" marL="0">
+              <a:spcAft>
+                <a:spcPts val="800"/>
+              </a:spcAft>
+              <a:buNone/>
+            </a:pPr>
+            <a:r>
+              <a:rPr lang="en-US" sz="3600" dirty="0">
+                <a:solidFill>
+                  <a:srgbClr val="111111"/>
+                </a:solidFill>
+                <a:latin typeface="Times New Roman" pitchFamily="34" charset="0"/>
+                <a:ea typeface="Times New Roman" pitchFamily="34" charset="-122"/>
+                <a:cs typeface="Times New Roman" pitchFamily="34" charset="-120"/>
+              </a:rPr>
+              <a:t>Inside a forest, the trees block the sun and the wind and release water vapour. The air is therefore shady, cool, humid and calm, with a small daily range of temperature.</a:t>
+            </a:r>
+            <a:endParaRPr lang="en-US" sz="3600" dirty="0"/>
+          </a:p>
+        </p:txBody>
+      </p:sp>
       <p:pic>
         <p:nvPicPr>
-          <p:cNvPr id="3" name="Image 0" descr="/home/claude/f4/img/minesec_sheet.png">    </p:cNvPr>
+          <p:cNvPr id="5" name="Image 0" descr="/home/claude/f4/img/v2/f2t_rainforest.jpg">    </p:cNvPr>
           <p:cNvPicPr>
             <a:picLocks noChangeAspect="1"/>
           </p:cNvPicPr>
@@ -16845,8 +17262,8 @@
         </p:blipFill>
         <p:spPr>
           <a:xfrm>
-            <a:off x="0" y="658368"/>
-            <a:ext cx="1463040" cy="5833872"/>
+            <a:off x="6537960" y="2400897"/>
+            <a:ext cx="5470855" cy="3034615"/>
           </a:xfrm>
           <a:prstGeom prst="rect">
             <a:avLst/>
@@ -16855,14 +17272,14 @@
       </p:pic>
       <p:sp>
         <p:nvSpPr>
-          <p:cNvPr id="4" name="Text 1"/>
+          <p:cNvPr id="6" name="Text 3"/>
           <p:cNvSpPr/>
           <p:nvPr/>
         </p:nvSpPr>
         <p:spPr>
           <a:xfrm>
-            <a:off x="1691640" y="1005840"/>
-            <a:ext cx="10180015" cy="731520"/>
+            <a:off x="6537960" y="6089904"/>
+            <a:ext cx="5470855" cy="347472"/>
           </a:xfrm>
           <a:prstGeom prst="rect">
             <a:avLst/>
@@ -16871,159 +17288,24 @@
           <a:ln/>
         </p:spPr>
         <p:txBody>
-          <a:bodyPr wrap="square" lIns="0" tIns="0" rIns="0" bIns="0" rtlCol="0" anchor="ctr">
-            <a:normAutofit/>
-          </a:bodyPr>
+          <a:bodyPr wrap="square" lIns="0" tIns="0" rIns="0" bIns="0" rtlCol="0" anchor="ctr"/>
           <a:lstStyle/>
           <a:p>
             <a:pPr algn="ctr" indent="0" marL="0">
               <a:buNone/>
             </a:pPr>
             <a:r>
-              <a:rPr lang="en-US" sz="3600" b="1" dirty="0">
-                <a:solidFill>
-                  <a:srgbClr val="990011"/>
+              <a:rPr lang="en-US" sz="1600" i="1" dirty="0">
+                <a:solidFill>
+                  <a:srgbClr val="555555"/>
                 </a:solidFill>
                 <a:latin typeface="Times New Roman" pitchFamily="34" charset="0"/>
                 <a:ea typeface="Times New Roman" pitchFamily="34" charset="-122"/>
                 <a:cs typeface="Times New Roman" pitchFamily="34" charset="-120"/>
               </a:rPr>
-              <a:t>2. Characteristics of Urban Climates</a:t>
-            </a:r>
-            <a:endParaRPr lang="en-US" sz="3600" dirty="0"/>
-          </a:p>
-        </p:txBody>
-      </p:sp>
-      <p:sp>
-        <p:nvSpPr>
-          <p:cNvPr id="5" name="Text 2"/>
-          <p:cNvSpPr/>
-          <p:nvPr/>
-        </p:nvSpPr>
-        <p:spPr>
-          <a:xfrm>
-            <a:off x="1691640" y="1783080"/>
-            <a:ext cx="10180015" cy="4663440"/>
-          </a:xfrm>
-          <a:prstGeom prst="rect">
-            <a:avLst/>
-          </a:prstGeom>
-          <a:noFill/>
-          <a:ln/>
-        </p:spPr>
-        <p:txBody>
-          <a:bodyPr wrap="square" lIns="0" tIns="0" rIns="0" bIns="0" rtlCol="0" anchor="t"/>
-          <a:lstStyle/>
-          <a:p>
-            <a:pPr algn="l" indent="0" marL="0">
-              <a:spcAft>
-                <a:spcPts val="800"/>
-              </a:spcAft>
-              <a:buNone/>
-            </a:pPr>
-            <a:r>
-              <a:rPr lang="en-US" sz="4000" b="1" dirty="0">
-                <a:solidFill>
-                  <a:srgbClr val="111111"/>
-                </a:solidFill>
-                <a:latin typeface="Times New Roman" pitchFamily="34" charset="0"/>
-                <a:ea typeface="Times New Roman" pitchFamily="34" charset="-122"/>
-                <a:cs typeface="Times New Roman" pitchFamily="34" charset="-120"/>
-              </a:rPr>
-              <a:t>Lower humidity: </a:t>
-            </a:r>
-            <a:pPr algn="l" indent="0" marL="0">
-              <a:spcAft>
-                <a:spcPts val="800"/>
-              </a:spcAft>
-              <a:buNone/>
-            </a:pPr>
-            <a:r>
-              <a:rPr lang="en-US" sz="4000" dirty="0">
-                <a:solidFill>
-                  <a:srgbClr val="111111"/>
-                </a:solidFill>
-                <a:latin typeface="Times New Roman" pitchFamily="34" charset="0"/>
-                <a:ea typeface="Times New Roman" pitchFamily="34" charset="-122"/>
-                <a:cs typeface="Times New Roman" pitchFamily="34" charset="-120"/>
-              </a:rPr>
-              <a:t>Fewer plants and less water mean less evapotranspiration and drier air.</a:t>
-            </a:r>
-            <a:endParaRPr lang="en-US" sz="4000" dirty="0"/>
-          </a:p>
-          <a:p>
-            <a:pPr algn="l" indent="0" marL="0">
-              <a:spcAft>
-                <a:spcPts val="800"/>
-              </a:spcAft>
-              <a:buNone/>
-            </a:pPr>
-            <a:r>
-              <a:rPr lang="en-US" sz="4000" b="1" dirty="0">
-                <a:solidFill>
-                  <a:srgbClr val="111111"/>
-                </a:solidFill>
-                <a:latin typeface="Times New Roman" pitchFamily="34" charset="0"/>
-                <a:ea typeface="Times New Roman" pitchFamily="34" charset="-122"/>
-                <a:cs typeface="Times New Roman" pitchFamily="34" charset="-120"/>
-              </a:rPr>
-              <a:t>Different winds: </a:t>
-            </a:r>
-            <a:pPr algn="l" indent="0" marL="0">
-              <a:spcAft>
-                <a:spcPts val="800"/>
-              </a:spcAft>
-              <a:buNone/>
-            </a:pPr>
-            <a:r>
-              <a:rPr lang="en-US" sz="4000" dirty="0">
-                <a:solidFill>
-                  <a:srgbClr val="111111"/>
-                </a:solidFill>
-                <a:latin typeface="Times New Roman" pitchFamily="34" charset="0"/>
-                <a:ea typeface="Times New Roman" pitchFamily="34" charset="-122"/>
-                <a:cs typeface="Times New Roman" pitchFamily="34" charset="-120"/>
-              </a:rPr>
-              <a:t>Buildings slow the wind or channel it along streets (canyon effect).</a:t>
-            </a:r>
-            <a:endParaRPr lang="en-US" sz="4000" dirty="0"/>
-          </a:p>
-          <a:p>
-            <a:pPr algn="l" indent="0" marL="0">
-              <a:spcAft>
-                <a:spcPts val="800"/>
-              </a:spcAft>
-              <a:buNone/>
-            </a:pPr>
-            <a:r>
-              <a:rPr lang="en-US" sz="4000" b="1" dirty="0">
-                <a:solidFill>
-                  <a:srgbClr val="111111"/>
-                </a:solidFill>
-                <a:latin typeface="Times New Roman" pitchFamily="34" charset="0"/>
-                <a:ea typeface="Times New Roman" pitchFamily="34" charset="-122"/>
-                <a:cs typeface="Times New Roman" pitchFamily="34" charset="-120"/>
-              </a:rPr>
-              <a:t>More pollution: </a:t>
-            </a:r>
-            <a:pPr algn="l" indent="0" marL="0">
-              <a:spcAft>
-                <a:spcPts val="800"/>
-              </a:spcAft>
-              <a:buNone/>
-            </a:pPr>
-            <a:r>
-              <a:rPr lang="en-US" sz="4000" dirty="0">
-                <a:solidFill>
-                  <a:srgbClr val="111111"/>
-                </a:solidFill>
-                <a:latin typeface="Times New Roman" pitchFamily="34" charset="0"/>
-                <a:ea typeface="Times New Roman" pitchFamily="34" charset="-122"/>
-                <a:cs typeface="Times New Roman" pitchFamily="34" charset="-120"/>
-              </a:rPr>
-              <a:t>Dust, smoke and gases from vehicles, generators and industries are concentrated.</a:t>
-            </a:r>
-            <a:endParaRPr lang="en-US" sz="4000" dirty="0"/>
+              <a:t>Illustration: a forest</a:t>
+            </a:r>
+            <a:endParaRPr lang="en-US" sz="1600" dirty="0"/>
           </a:p>
         </p:txBody>
       </p:sp>
@@ -17174,7 +17456,7 @@
                 <a:ea typeface="Times New Roman" pitchFamily="34" charset="-122"/>
                 <a:cs typeface="Times New Roman" pitchFamily="34" charset="-120"/>
               </a:rPr>
-              <a:t>2. Characteristics of Urban Climates</a:t>
+              <a:t>3. Characteristics of Urban Climates</a:t>
             </a:r>
             <a:endParaRPr lang="en-US" sz="3600" dirty="0"/>
           </a:p>
@@ -17189,7 +17471,7 @@
         <p:spPr>
           <a:xfrm>
             <a:off x="365760" y="1783080"/>
-            <a:ext cx="4846320" cy="4617720"/>
+            <a:ext cx="6035040" cy="4617720"/>
           </a:xfrm>
           <a:prstGeom prst="rect">
             <a:avLst/>
@@ -17208,7 +17490,7 @@
               <a:buNone/>
             </a:pPr>
             <a:r>
-              <a:rPr lang="en-US" sz="3600" b="1" dirty="0">
+              <a:rPr lang="en-US" sz="3200" i="1" dirty="0">
                 <a:solidFill>
                   <a:srgbClr val="111111"/>
                 </a:solidFill>
@@ -17216,8 +17498,11 @@
                 <a:ea typeface="Times New Roman" pitchFamily="34" charset="-122"/>
                 <a:cs typeface="Times New Roman" pitchFamily="34" charset="-120"/>
               </a:rPr>
-              <a:t>Slightly more rain: </a:t>
-            </a:r>
+              <a:t>Compared with the countryside, towns have the following climatic characteristics:</a:t>
+            </a:r>
+            <a:endParaRPr lang="en-US" sz="3200" dirty="0"/>
+          </a:p>
+          <a:p>
             <a:pPr algn="l" indent="0" marL="0">
               <a:spcAft>
                 <a:spcPts val="800"/>
@@ -17225,7 +17510,7 @@
               <a:buNone/>
             </a:pPr>
             <a:r>
-              <a:rPr lang="en-US" sz="3600" dirty="0">
+              <a:rPr lang="en-US" sz="3200" b="1" dirty="0">
                 <a:solidFill>
                   <a:srgbClr val="111111"/>
                 </a:solidFill>
@@ -17233,15 +17518,32 @@
                 <a:ea typeface="Times New Roman" pitchFamily="34" charset="-122"/>
                 <a:cs typeface="Times New Roman" pitchFamily="34" charset="-120"/>
               </a:rPr>
-              <a:t>Extra heat and particles can trigger convectional storms over the city.</a:t>
-            </a:r>
-            <a:endParaRPr lang="en-US" sz="3600" dirty="0"/>
+              <a:t>Higher temperatures: </a:t>
+            </a:r>
+            <a:pPr algn="l" indent="0" marL="0">
+              <a:spcAft>
+                <a:spcPts val="800"/>
+              </a:spcAft>
+              <a:buNone/>
+            </a:pPr>
+            <a:r>
+              <a:rPr lang="en-US" sz="3200" dirty="0">
+                <a:solidFill>
+                  <a:srgbClr val="111111"/>
+                </a:solidFill>
+                <a:latin typeface="Times New Roman" pitchFamily="34" charset="0"/>
+                <a:ea typeface="Times New Roman" pitchFamily="34" charset="-122"/>
+                <a:cs typeface="Times New Roman" pitchFamily="34" charset="-120"/>
+              </a:rPr>
+              <a:t>Towns are warmer than the countryside, especially at night, by 2 to 5 °C in large cities. This is the urban heat island, strongest in the town centre.</a:t>
+            </a:r>
+            <a:endParaRPr lang="en-US" sz="3200" dirty="0"/>
           </a:p>
         </p:txBody>
       </p:sp>
       <p:pic>
         <p:nvPicPr>
-          <p:cNvPr id="5" name="Image 0" descr="/home/claude/f4/img/v2/clim2_urban.png">    </p:cNvPr>
+          <p:cNvPr id="5" name="Image 0" descr="/home/claude/f4/img/v2/heat_island_big.png">    </p:cNvPr>
           <p:cNvPicPr>
             <a:picLocks noChangeAspect="1"/>
           </p:cNvPicPr>
@@ -17255,8 +17557,8 @@
         </p:blipFill>
         <p:spPr>
           <a:xfrm>
-            <a:off x="5349240" y="2617506"/>
-            <a:ext cx="6659575" cy="2601397"/>
+            <a:off x="6537960" y="2849678"/>
+            <a:ext cx="5470855" cy="2137053"/>
           </a:xfrm>
           <a:prstGeom prst="rect">
             <a:avLst/>
@@ -17271,8 +17573,8 @@
         </p:nvSpPr>
         <p:spPr>
           <a:xfrm>
-            <a:off x="5349240" y="6089904"/>
-            <a:ext cx="6659575" cy="347472"/>
+            <a:off x="6537960" y="6089904"/>
+            <a:ext cx="5470855" cy="347472"/>
           </a:xfrm>
           <a:prstGeom prst="rect">
             <a:avLst/>
@@ -17296,7 +17598,7 @@
                 <a:ea typeface="Times New Roman" pitchFamily="34" charset="-122"/>
                 <a:cs typeface="Times New Roman" pitchFamily="34" charset="-120"/>
               </a:rPr>
-              <a:t>Illustration: town and countryside compared</a:t>
+              <a:t>Illustration: the urban heat island</a:t>
             </a:r>
             <a:endParaRPr lang="en-US" sz="1600" dirty="0"/>
           </a:p>
@@ -17414,129 +17716,9 @@
           </a:p>
         </p:txBody>
       </p:sp>
-      <p:sp>
-        <p:nvSpPr>
-          <p:cNvPr id="3" name="Text 1"/>
-          <p:cNvSpPr/>
-          <p:nvPr/>
-        </p:nvSpPr>
-        <p:spPr>
-          <a:xfrm>
-            <a:off x="365760" y="1005840"/>
-            <a:ext cx="11460175" cy="731520"/>
-          </a:xfrm>
-          <a:prstGeom prst="rect">
-            <a:avLst/>
-          </a:prstGeom>
-          <a:noFill/>
-          <a:ln/>
-        </p:spPr>
-        <p:txBody>
-          <a:bodyPr wrap="square" lIns="0" tIns="0" rIns="0" bIns="0" rtlCol="0" anchor="ctr">
-            <a:normAutofit/>
-          </a:bodyPr>
-          <a:lstStyle/>
-          <a:p>
-            <a:pPr algn="ctr" indent="0" marL="0">
-              <a:buNone/>
-            </a:pPr>
-            <a:r>
-              <a:rPr lang="en-US" sz="3600" b="1" dirty="0">
-                <a:solidFill>
-                  <a:srgbClr val="990011"/>
-                </a:solidFill>
-                <a:latin typeface="Times New Roman" pitchFamily="34" charset="0"/>
-                <a:ea typeface="Times New Roman" pitchFamily="34" charset="-122"/>
-                <a:cs typeface="Times New Roman" pitchFamily="34" charset="-120"/>
-              </a:rPr>
-              <a:t>3. Factors of the Urban Heat Island</a:t>
-            </a:r>
-            <a:endParaRPr lang="en-US" sz="3600" dirty="0"/>
-          </a:p>
-        </p:txBody>
-      </p:sp>
-      <p:sp>
-        <p:nvSpPr>
-          <p:cNvPr id="4" name="Text 2"/>
-          <p:cNvSpPr/>
-          <p:nvPr/>
-        </p:nvSpPr>
-        <p:spPr>
-          <a:xfrm>
-            <a:off x="365760" y="1783080"/>
-            <a:ext cx="4846320" cy="4617720"/>
-          </a:xfrm>
-          <a:prstGeom prst="rect">
-            <a:avLst/>
-          </a:prstGeom>
-          <a:noFill/>
-          <a:ln/>
-        </p:spPr>
-        <p:txBody>
-          <a:bodyPr wrap="square" lIns="0" tIns="0" rIns="0" bIns="0" rtlCol="0" anchor="t"/>
-          <a:lstStyle/>
-          <a:p>
-            <a:pPr algn="l" indent="0" marL="0">
-              <a:spcAft>
-                <a:spcPts val="800"/>
-              </a:spcAft>
-              <a:buNone/>
-            </a:pPr>
-            <a:r>
-              <a:rPr lang="en-US" sz="3600" i="1" dirty="0">
-                <a:solidFill>
-                  <a:srgbClr val="111111"/>
-                </a:solidFill>
-                <a:latin typeface="Times New Roman" pitchFamily="34" charset="0"/>
-                <a:ea typeface="Times New Roman" pitchFamily="34" charset="-122"/>
-                <a:cs typeface="Times New Roman" pitchFamily="34" charset="-120"/>
-              </a:rPr>
-              <a:t>The urban heat island is caused by the following factors:</a:t>
-            </a:r>
-            <a:endParaRPr lang="en-US" sz="3600" dirty="0"/>
-          </a:p>
-          <a:p>
-            <a:pPr algn="l" indent="0" marL="0">
-              <a:spcAft>
-                <a:spcPts val="800"/>
-              </a:spcAft>
-              <a:buNone/>
-            </a:pPr>
-            <a:r>
-              <a:rPr lang="en-US" sz="3600" b="1" dirty="0">
-                <a:solidFill>
-                  <a:srgbClr val="111111"/>
-                </a:solidFill>
-                <a:latin typeface="Times New Roman" pitchFamily="34" charset="0"/>
-                <a:ea typeface="Times New Roman" pitchFamily="34" charset="-122"/>
-                <a:cs typeface="Times New Roman" pitchFamily="34" charset="-120"/>
-              </a:rPr>
-              <a:t>Surfaces: </a:t>
-            </a:r>
-            <a:pPr algn="l" indent="0" marL="0">
-              <a:spcAft>
-                <a:spcPts val="800"/>
-              </a:spcAft>
-              <a:buNone/>
-            </a:pPr>
-            <a:r>
-              <a:rPr lang="en-US" sz="3600" dirty="0">
-                <a:solidFill>
-                  <a:srgbClr val="111111"/>
-                </a:solidFill>
-                <a:latin typeface="Times New Roman" pitchFamily="34" charset="0"/>
-                <a:ea typeface="Times New Roman" pitchFamily="34" charset="-122"/>
-                <a:cs typeface="Times New Roman" pitchFamily="34" charset="-120"/>
-              </a:rPr>
-              <a:t>Tarred roads, concrete and bricks absorb solar energy by day and release it slowly at night.</a:t>
-            </a:r>
-            <a:endParaRPr lang="en-US" sz="3600" dirty="0"/>
-          </a:p>
-        </p:txBody>
-      </p:sp>
       <p:pic>
         <p:nvPicPr>
-          <p:cNvPr id="5" name="Image 0" descr="/home/claude/f4/img/v2/lsa_douala.jpg">    </p:cNvPr>
+          <p:cNvPr id="3" name="Image 0" descr="/home/claude/f4/img/minesec_sheet.png">    </p:cNvPr>
           <p:cNvPicPr>
             <a:picLocks noChangeAspect="1"/>
           </p:cNvPicPr>
@@ -17550,8 +17732,8 @@
         </p:blipFill>
         <p:spPr>
           <a:xfrm>
-            <a:off x="5349240" y="2071212"/>
-            <a:ext cx="6659575" cy="3693983"/>
+            <a:off x="0" y="658368"/>
+            <a:ext cx="5120640" cy="5833872"/>
           </a:xfrm>
           <a:prstGeom prst="rect">
             <a:avLst/>
@@ -17560,14 +17742,14 @@
       </p:pic>
       <p:sp>
         <p:nvSpPr>
-          <p:cNvPr id="6" name="Text 3"/>
+          <p:cNvPr id="4" name="Text 1"/>
           <p:cNvSpPr/>
           <p:nvPr/>
         </p:nvSpPr>
         <p:spPr>
           <a:xfrm>
-            <a:off x="5349240" y="6089904"/>
-            <a:ext cx="6659575" cy="347472"/>
+            <a:off x="5349240" y="1005840"/>
+            <a:ext cx="6522415" cy="731520"/>
           </a:xfrm>
           <a:prstGeom prst="rect">
             <a:avLst/>
@@ -17576,24 +17758,85 @@
           <a:ln/>
         </p:spPr>
         <p:txBody>
-          <a:bodyPr wrap="square" lIns="0" tIns="0" rIns="0" bIns="0" rtlCol="0" anchor="ctr"/>
+          <a:bodyPr wrap="square" lIns="0" tIns="0" rIns="0" bIns="0" rtlCol="0" anchor="ctr">
+            <a:normAutofit/>
+          </a:bodyPr>
           <a:lstStyle/>
           <a:p>
             <a:pPr algn="ctr" indent="0" marL="0">
               <a:buNone/>
             </a:pPr>
             <a:r>
-              <a:rPr lang="en-US" sz="1600" i="1" dirty="0">
-                <a:solidFill>
-                  <a:srgbClr val="555555"/>
+              <a:rPr lang="en-US" sz="3600" b="1" dirty="0">
+                <a:solidFill>
+                  <a:srgbClr val="990011"/>
                 </a:solidFill>
                 <a:latin typeface="Times New Roman" pitchFamily="34" charset="0"/>
                 <a:ea typeface="Times New Roman" pitchFamily="34" charset="-122"/>
                 <a:cs typeface="Times New Roman" pitchFamily="34" charset="-120"/>
               </a:rPr>
-              <a:t>Illustration: a large city</a:t>
-            </a:r>
-            <a:endParaRPr lang="en-US" sz="1600" dirty="0"/>
+              <a:t>3. Characteristics of Urban Climates</a:t>
+            </a:r>
+            <a:endParaRPr lang="en-US" sz="3600" dirty="0"/>
+          </a:p>
+        </p:txBody>
+      </p:sp>
+      <p:sp>
+        <p:nvSpPr>
+          <p:cNvPr id="5" name="Text 2"/>
+          <p:cNvSpPr/>
+          <p:nvPr/>
+        </p:nvSpPr>
+        <p:spPr>
+          <a:xfrm>
+            <a:off x="5349240" y="1783080"/>
+            <a:ext cx="6522415" cy="4663440"/>
+          </a:xfrm>
+          <a:prstGeom prst="rect">
+            <a:avLst/>
+          </a:prstGeom>
+          <a:noFill/>
+          <a:ln/>
+        </p:spPr>
+        <p:txBody>
+          <a:bodyPr wrap="square" lIns="0" tIns="0" rIns="0" bIns="0" rtlCol="0" anchor="t"/>
+          <a:lstStyle/>
+          <a:p>
+            <a:pPr algn="l" indent="0" marL="0">
+              <a:spcAft>
+                <a:spcPts val="800"/>
+              </a:spcAft>
+              <a:buNone/>
+            </a:pPr>
+            <a:r>
+              <a:rPr lang="en-US" sz="4000" b="1" dirty="0">
+                <a:solidFill>
+                  <a:srgbClr val="111111"/>
+                </a:solidFill>
+                <a:latin typeface="Times New Roman" pitchFamily="34" charset="0"/>
+                <a:ea typeface="Times New Roman" pitchFamily="34" charset="-122"/>
+                <a:cs typeface="Times New Roman" pitchFamily="34" charset="-120"/>
+              </a:rPr>
+              <a:t>Lower humidity: </a:t>
+            </a:r>
+            <a:pPr algn="l" indent="0" marL="0">
+              <a:spcAft>
+                <a:spcPts val="800"/>
+              </a:spcAft>
+              <a:buNone/>
+            </a:pPr>
+            <a:r>
+              <a:rPr lang="en-US" sz="4000" dirty="0">
+                <a:solidFill>
+                  <a:srgbClr val="111111"/>
+                </a:solidFill>
+                <a:latin typeface="Times New Roman" pitchFamily="34" charset="0"/>
+                <a:ea typeface="Times New Roman" pitchFamily="34" charset="-122"/>
+                <a:cs typeface="Times New Roman" pitchFamily="34" charset="-120"/>
+              </a:rPr>
+              <a:t>Rainwater runs quickly into drains, and there are few plants and little open water. As a result, there is less evapotranspiration and the air is drier.</a:t>
+            </a:r>
+            <a:endParaRPr lang="en-US" sz="4000" dirty="0"/>
           </a:p>
         </p:txBody>
       </p:sp>
@@ -17726,7 +17969,7 @@
         <p:spPr>
           <a:xfrm>
             <a:off x="0" y="658368"/>
-            <a:ext cx="3840480" cy="5833872"/>
+            <a:ext cx="5120640" cy="5833872"/>
           </a:xfrm>
           <a:prstGeom prst="rect">
             <a:avLst/>
@@ -17741,8 +17984,8 @@
         </p:nvSpPr>
         <p:spPr>
           <a:xfrm>
-            <a:off x="4069080" y="1005840"/>
-            <a:ext cx="7802575" cy="731520"/>
+            <a:off x="5349240" y="1005840"/>
+            <a:ext cx="6522415" cy="731520"/>
           </a:xfrm>
           <a:prstGeom prst="rect">
             <a:avLst/>
@@ -17768,7 +18011,7 @@
                 <a:ea typeface="Times New Roman" pitchFamily="34" charset="-122"/>
                 <a:cs typeface="Times New Roman" pitchFamily="34" charset="-120"/>
               </a:rPr>
-              <a:t>3. Factors of the Urban Heat Island</a:t>
+              <a:t>3. Characteristics of Urban Climates</a:t>
             </a:r>
             <a:endParaRPr lang="en-US" sz="3600" dirty="0"/>
           </a:p>
@@ -17782,8 +18025,8 @@
         </p:nvSpPr>
         <p:spPr>
           <a:xfrm>
-            <a:off x="4069080" y="1783080"/>
-            <a:ext cx="7802575" cy="4663440"/>
+            <a:off x="5349240" y="1783080"/>
+            <a:ext cx="6522415" cy="4663440"/>
           </a:xfrm>
           <a:prstGeom prst="rect">
             <a:avLst/>
@@ -17810,7 +18053,7 @@
                 <a:ea typeface="Times New Roman" pitchFamily="34" charset="-122"/>
                 <a:cs typeface="Times New Roman" pitchFamily="34" charset="-120"/>
               </a:rPr>
-              <a:t>Anthropogenic heat: </a:t>
+              <a:t>Modified winds: </a:t>
             </a:r>
             <a:pPr algn="l" indent="0" marL="0">
               <a:spcAft>
@@ -17827,44 +18070,7 @@
                 <a:ea typeface="Times New Roman" pitchFamily="34" charset="-122"/>
                 <a:cs typeface="Times New Roman" pitchFamily="34" charset="-120"/>
               </a:rPr>
-              <a:t>Cars, moto-taxis, generators, air conditioners, factories and crowds release heat.</a:t>
-            </a:r>
-            <a:endParaRPr lang="en-US" sz="4000" dirty="0"/>
-          </a:p>
-          <a:p>
-            <a:pPr algn="l" indent="0" marL="0">
-              <a:spcAft>
-                <a:spcPts val="800"/>
-              </a:spcAft>
-              <a:buNone/>
-            </a:pPr>
-            <a:r>
-              <a:rPr lang="en-US" sz="4000" b="1" dirty="0">
-                <a:solidFill>
-                  <a:srgbClr val="111111"/>
-                </a:solidFill>
-                <a:latin typeface="Times New Roman" pitchFamily="34" charset="0"/>
-                <a:ea typeface="Times New Roman" pitchFamily="34" charset="-122"/>
-                <a:cs typeface="Times New Roman" pitchFamily="34" charset="-120"/>
-              </a:rPr>
-              <a:t>Reduced evapotranspiration: </a:t>
-            </a:r>
-            <a:pPr algn="l" indent="0" marL="0">
-              <a:spcAft>
-                <a:spcPts val="800"/>
-              </a:spcAft>
-              <a:buNone/>
-            </a:pPr>
-            <a:r>
-              <a:rPr lang="en-US" sz="4000" dirty="0">
-                <a:solidFill>
-                  <a:srgbClr val="111111"/>
-                </a:solidFill>
-                <a:latin typeface="Times New Roman" pitchFamily="34" charset="0"/>
-                <a:ea typeface="Times New Roman" pitchFamily="34" charset="-122"/>
-                <a:cs typeface="Times New Roman" pitchFamily="34" charset="-120"/>
-              </a:rPr>
-              <a:t>Few trees, gardens and open soils mean little natural cooling.</a:t>
+              <a:t>Buildings slow down the wind, so towns are generally calmer. However, wind can be channelled and strengthened in narrow streets between tall buildings.</a:t>
             </a:r>
             <a:endParaRPr lang="en-US" sz="4000" dirty="0"/>
           </a:p>
@@ -17982,9 +18188,109 @@
           </a:p>
         </p:txBody>
       </p:sp>
+      <p:sp>
+        <p:nvSpPr>
+          <p:cNvPr id="3" name="Text 1"/>
+          <p:cNvSpPr/>
+          <p:nvPr/>
+        </p:nvSpPr>
+        <p:spPr>
+          <a:xfrm>
+            <a:off x="365760" y="1005840"/>
+            <a:ext cx="11460175" cy="731520"/>
+          </a:xfrm>
+          <a:prstGeom prst="rect">
+            <a:avLst/>
+          </a:prstGeom>
+          <a:noFill/>
+          <a:ln/>
+        </p:spPr>
+        <p:txBody>
+          <a:bodyPr wrap="square" lIns="0" tIns="0" rIns="0" bIns="0" rtlCol="0" anchor="ctr">
+            <a:normAutofit/>
+          </a:bodyPr>
+          <a:lstStyle/>
+          <a:p>
+            <a:pPr algn="ctr" indent="0" marL="0">
+              <a:buNone/>
+            </a:pPr>
+            <a:r>
+              <a:rPr lang="en-US" sz="3600" b="1" dirty="0">
+                <a:solidFill>
+                  <a:srgbClr val="990011"/>
+                </a:solidFill>
+                <a:latin typeface="Times New Roman" pitchFamily="34" charset="0"/>
+                <a:ea typeface="Times New Roman" pitchFamily="34" charset="-122"/>
+                <a:cs typeface="Times New Roman" pitchFamily="34" charset="-120"/>
+              </a:rPr>
+              <a:t>3. Characteristics of Urban Climates</a:t>
+            </a:r>
+            <a:endParaRPr lang="en-US" sz="3600" dirty="0"/>
+          </a:p>
+        </p:txBody>
+      </p:sp>
+      <p:sp>
+        <p:nvSpPr>
+          <p:cNvPr id="4" name="Text 2"/>
+          <p:cNvSpPr/>
+          <p:nvPr/>
+        </p:nvSpPr>
+        <p:spPr>
+          <a:xfrm>
+            <a:off x="365760" y="1783080"/>
+            <a:ext cx="6035040" cy="4617720"/>
+          </a:xfrm>
+          <a:prstGeom prst="rect">
+            <a:avLst/>
+          </a:prstGeom>
+          <a:noFill/>
+          <a:ln/>
+        </p:spPr>
+        <p:txBody>
+          <a:bodyPr wrap="square" lIns="0" tIns="0" rIns="0" bIns="0" rtlCol="0" anchor="t"/>
+          <a:lstStyle/>
+          <a:p>
+            <a:pPr algn="l" indent="0" marL="0">
+              <a:spcAft>
+                <a:spcPts val="800"/>
+              </a:spcAft>
+              <a:buNone/>
+            </a:pPr>
+            <a:r>
+              <a:rPr lang="en-US" sz="3400" b="1" dirty="0">
+                <a:solidFill>
+                  <a:srgbClr val="111111"/>
+                </a:solidFill>
+                <a:latin typeface="Times New Roman" pitchFamily="34" charset="0"/>
+                <a:ea typeface="Times New Roman" pitchFamily="34" charset="-122"/>
+                <a:cs typeface="Times New Roman" pitchFamily="34" charset="-120"/>
+              </a:rPr>
+              <a:t>More pollution and more rain: </a:t>
+            </a:r>
+            <a:pPr algn="l" indent="0" marL="0">
+              <a:spcAft>
+                <a:spcPts val="800"/>
+              </a:spcAft>
+              <a:buNone/>
+            </a:pPr>
+            <a:r>
+              <a:rPr lang="en-US" sz="3400" dirty="0">
+                <a:solidFill>
+                  <a:srgbClr val="111111"/>
+                </a:solidFill>
+                <a:latin typeface="Times New Roman" pitchFamily="34" charset="0"/>
+                <a:ea typeface="Times New Roman" pitchFamily="34" charset="-122"/>
+                <a:cs typeface="Times New Roman" pitchFamily="34" charset="-120"/>
+              </a:rPr>
+              <a:t>Dust, smoke and gases from vehicles, generators and factories are concentrated over towns. These particles and the extra heat can trigger more convectional storms over and downwind of large cities.</a:t>
+            </a:r>
+            <a:endParaRPr lang="en-US" sz="3400" dirty="0"/>
+          </a:p>
+        </p:txBody>
+      </p:sp>
       <p:pic>
         <p:nvPicPr>
-          <p:cNvPr id="3" name="Image 0" descr="/home/claude/f4/img/minesec_sheet.png">    </p:cNvPr>
+          <p:cNvPr id="5" name="Image 0" descr="/home/claude/f4/img/v2/clim2_urban.png">    </p:cNvPr>
           <p:cNvPicPr>
             <a:picLocks noChangeAspect="1"/>
           </p:cNvPicPr>
@@ -17998,8 +18304,8 @@
         </p:blipFill>
         <p:spPr>
           <a:xfrm>
-            <a:off x="0" y="658368"/>
-            <a:ext cx="3840480" cy="5833872"/>
+            <a:off x="6537960" y="2849678"/>
+            <a:ext cx="5470855" cy="2137053"/>
           </a:xfrm>
           <a:prstGeom prst="rect">
             <a:avLst/>
@@ -18008,14 +18314,14 @@
       </p:pic>
       <p:sp>
         <p:nvSpPr>
-          <p:cNvPr id="4" name="Text 1"/>
+          <p:cNvPr id="6" name="Text 3"/>
           <p:cNvSpPr/>
           <p:nvPr/>
         </p:nvSpPr>
         <p:spPr>
           <a:xfrm>
-            <a:off x="4069080" y="1005840"/>
-            <a:ext cx="7802575" cy="731520"/>
+            <a:off x="6537960" y="6089904"/>
+            <a:ext cx="5470855" cy="347472"/>
           </a:xfrm>
           <a:prstGeom prst="rect">
             <a:avLst/>
@@ -18024,122 +18330,24 @@
           <a:ln/>
         </p:spPr>
         <p:txBody>
-          <a:bodyPr wrap="square" lIns="0" tIns="0" rIns="0" bIns="0" rtlCol="0" anchor="ctr">
-            <a:normAutofit/>
-          </a:bodyPr>
+          <a:bodyPr wrap="square" lIns="0" tIns="0" rIns="0" bIns="0" rtlCol="0" anchor="ctr"/>
           <a:lstStyle/>
           <a:p>
             <a:pPr algn="ctr" indent="0" marL="0">
               <a:buNone/>
             </a:pPr>
             <a:r>
-              <a:rPr lang="en-US" sz="3600" b="1" dirty="0">
-                <a:solidFill>
-                  <a:srgbClr val="990011"/>
+              <a:rPr lang="en-US" sz="1600" i="1" dirty="0">
+                <a:solidFill>
+                  <a:srgbClr val="555555"/>
                 </a:solidFill>
                 <a:latin typeface="Times New Roman" pitchFamily="34" charset="0"/>
                 <a:ea typeface="Times New Roman" pitchFamily="34" charset="-122"/>
                 <a:cs typeface="Times New Roman" pitchFamily="34" charset="-120"/>
               </a:rPr>
-              <a:t>3. Factors of the Urban Heat Island (continued)</a:t>
-            </a:r>
-            <a:endParaRPr lang="en-US" sz="3600" dirty="0"/>
-          </a:p>
-        </p:txBody>
-      </p:sp>
-      <p:sp>
-        <p:nvSpPr>
-          <p:cNvPr id="5" name="Text 2"/>
-          <p:cNvSpPr/>
-          <p:nvPr/>
-        </p:nvSpPr>
-        <p:spPr>
-          <a:xfrm>
-            <a:off x="4069080" y="1783080"/>
-            <a:ext cx="7802575" cy="4663440"/>
-          </a:xfrm>
-          <a:prstGeom prst="rect">
-            <a:avLst/>
-          </a:prstGeom>
-          <a:noFill/>
-          <a:ln/>
-        </p:spPr>
-        <p:txBody>
-          <a:bodyPr wrap="square" lIns="0" tIns="0" rIns="0" bIns="0" rtlCol="0" anchor="t"/>
-          <a:lstStyle/>
-          <a:p>
-            <a:pPr algn="l" indent="0" marL="0">
-              <a:spcAft>
-                <a:spcPts val="800"/>
-              </a:spcAft>
-              <a:buNone/>
-            </a:pPr>
-            <a:r>
-              <a:rPr lang="en-US" sz="4000" b="1" dirty="0">
-                <a:solidFill>
-                  <a:srgbClr val="111111"/>
-                </a:solidFill>
-                <a:latin typeface="Times New Roman" pitchFamily="34" charset="0"/>
-                <a:ea typeface="Times New Roman" pitchFamily="34" charset="-122"/>
-                <a:cs typeface="Times New Roman" pitchFamily="34" charset="-120"/>
-              </a:rPr>
-              <a:t>Urban geometry: </a:t>
-            </a:r>
-            <a:pPr algn="l" indent="0" marL="0">
-              <a:spcAft>
-                <a:spcPts val="800"/>
-              </a:spcAft>
-              <a:buNone/>
-            </a:pPr>
-            <a:r>
-              <a:rPr lang="en-US" sz="4000" dirty="0">
-                <a:solidFill>
-                  <a:srgbClr val="111111"/>
-                </a:solidFill>
-                <a:latin typeface="Times New Roman" pitchFamily="34" charset="0"/>
-                <a:ea typeface="Times New Roman" pitchFamily="34" charset="-122"/>
-                <a:cs typeface="Times New Roman" pitchFamily="34" charset="-120"/>
-              </a:rPr>
-              <a:t>Tall buildings and narrow streets form "urban canyons" that trap heat and block the wind.</a:t>
-            </a:r>
-            <a:endParaRPr lang="en-US" sz="4000" dirty="0"/>
-          </a:p>
-          <a:p>
-            <a:pPr algn="l" indent="0" marL="0">
-              <a:spcAft>
-                <a:spcPts val="800"/>
-              </a:spcAft>
-              <a:buNone/>
-            </a:pPr>
-            <a:r>
-              <a:rPr lang="en-US" sz="4000" b="1" dirty="0">
-                <a:solidFill>
-                  <a:srgbClr val="111111"/>
-                </a:solidFill>
-                <a:latin typeface="Times New Roman" pitchFamily="34" charset="0"/>
-                <a:ea typeface="Times New Roman" pitchFamily="34" charset="-122"/>
-                <a:cs typeface="Times New Roman" pitchFamily="34" charset="-120"/>
-              </a:rPr>
-              <a:t>Solutions: </a:t>
-            </a:r>
-            <a:pPr algn="l" indent="0" marL="0">
-              <a:spcAft>
-                <a:spcPts val="800"/>
-              </a:spcAft>
-              <a:buNone/>
-            </a:pPr>
-            <a:r>
-              <a:rPr lang="en-US" sz="4000" dirty="0">
-                <a:solidFill>
-                  <a:srgbClr val="111111"/>
-                </a:solidFill>
-                <a:latin typeface="Times New Roman" pitchFamily="34" charset="0"/>
-                <a:ea typeface="Times New Roman" pitchFamily="34" charset="-122"/>
-                <a:cs typeface="Times New Roman" pitchFamily="34" charset="-120"/>
-              </a:rPr>
-              <a:t>Trees, parks, light roofs and less traffic reduce urban heat.</a:t>
-            </a:r>
-            <a:endParaRPr lang="en-US" sz="4000" dirty="0"/>
+              <a:t>Illustration: the urban climate</a:t>
+            </a:r>
+            <a:endParaRPr lang="en-US" sz="1600" dirty="0"/>
           </a:p>
         </p:txBody>
       </p:sp>
@@ -18249,7 +18457,7 @@
                 <a:ea typeface="Calibri" pitchFamily="34" charset="-122"/>
                 <a:cs typeface="Calibri" pitchFamily="34" charset="-120"/>
               </a:rPr>
-              <a:t>FORMATIVE EVALUATION</a:t>
+              <a:t>BOARD SUMMARY</a:t>
             </a:r>
             <a:endParaRPr lang="en-US" sz="1400" dirty="0"/>
           </a:p>
@@ -18272,7 +18480,7 @@
         <p:spPr>
           <a:xfrm>
             <a:off x="0" y="658368"/>
-            <a:ext cx="5120640" cy="5833872"/>
+            <a:ext cx="1463040" cy="5833872"/>
           </a:xfrm>
           <a:prstGeom prst="rect">
             <a:avLst/>
@@ -18287,8 +18495,8 @@
         </p:nvSpPr>
         <p:spPr>
           <a:xfrm>
-            <a:off x="5349240" y="1005840"/>
-            <a:ext cx="6522415" cy="731520"/>
+            <a:off x="1691640" y="1005840"/>
+            <a:ext cx="10180015" cy="731520"/>
           </a:xfrm>
           <a:prstGeom prst="rect">
             <a:avLst/>
@@ -18314,7 +18522,7 @@
                 <a:ea typeface="Times New Roman" pitchFamily="34" charset="-122"/>
                 <a:cs typeface="Times New Roman" pitchFamily="34" charset="-120"/>
               </a:rPr>
-              <a:t>Evaluation 1</a:t>
+              <a:t>4. Factors of Urban Climates</a:t>
             </a:r>
             <a:endParaRPr lang="en-US" sz="3600" dirty="0"/>
           </a:p>
@@ -18328,8 +18536,8 @@
         </p:nvSpPr>
         <p:spPr>
           <a:xfrm>
-            <a:off x="5349240" y="1783080"/>
-            <a:ext cx="6522415" cy="4663440"/>
+            <a:off x="1691640" y="1783080"/>
+            <a:ext cx="10180015" cy="4663440"/>
           </a:xfrm>
           <a:prstGeom prst="rect">
             <a:avLst/>
@@ -18348,7 +18556,7 @@
               <a:buNone/>
             </a:pPr>
             <a:r>
-              <a:rPr lang="en-US" sz="4000" dirty="0">
+              <a:rPr lang="en-US" sz="4000" i="1" dirty="0">
                 <a:solidFill>
                   <a:srgbClr val="111111"/>
                 </a:solidFill>
@@ -18356,7 +18564,44 @@
                 <a:ea typeface="Times New Roman" pitchFamily="34" charset="-122"/>
                 <a:cs typeface="Times New Roman" pitchFamily="34" charset="-120"/>
               </a:rPr>
-              <a:t>What is the urban heat island, and give two of its causes in Garoua?</a:t>
+              <a:t>The urban climate is explained by the following factors:</a:t>
+            </a:r>
+            <a:endParaRPr lang="en-US" sz="4000" dirty="0"/>
+          </a:p>
+          <a:p>
+            <a:pPr algn="l" indent="0" marL="0">
+              <a:spcAft>
+                <a:spcPts val="800"/>
+              </a:spcAft>
+              <a:buNone/>
+            </a:pPr>
+            <a:r>
+              <a:rPr lang="en-US" sz="4000" b="1" dirty="0">
+                <a:solidFill>
+                  <a:srgbClr val="111111"/>
+                </a:solidFill>
+                <a:latin typeface="Times New Roman" pitchFamily="34" charset="0"/>
+                <a:ea typeface="Times New Roman" pitchFamily="34" charset="-122"/>
+                <a:cs typeface="Times New Roman" pitchFamily="34" charset="-120"/>
+              </a:rPr>
+              <a:t>Artificial surfaces: </a:t>
+            </a:r>
+            <a:pPr algn="l" indent="0" marL="0">
+              <a:spcAft>
+                <a:spcPts val="800"/>
+              </a:spcAft>
+              <a:buNone/>
+            </a:pPr>
+            <a:r>
+              <a:rPr lang="en-US" sz="4000" dirty="0">
+                <a:solidFill>
+                  <a:srgbClr val="111111"/>
+                </a:solidFill>
+                <a:latin typeface="Times New Roman" pitchFamily="34" charset="0"/>
+                <a:ea typeface="Times New Roman" pitchFamily="34" charset="-122"/>
+                <a:cs typeface="Times New Roman" pitchFamily="34" charset="-120"/>
+              </a:rPr>
+              <a:t>Tarred roads, concrete and bricks absorb much solar energy by day and release it slowly at night. They also make rainwater run off quickly, so less water is available for evaporation.</a:t>
             </a:r>
             <a:endParaRPr lang="en-US" sz="4000" dirty="0"/>
           </a:p>
@@ -18687,7 +18932,7 @@
                 <a:ea typeface="Calibri" pitchFamily="34" charset="-122"/>
                 <a:cs typeface="Calibri" pitchFamily="34" charset="-120"/>
               </a:rPr>
-              <a:t>FORMATIVE EVALUATION</a:t>
+              <a:t>BOARD SUMMARY</a:t>
             </a:r>
             <a:endParaRPr lang="en-US" sz="1400" dirty="0"/>
           </a:p>
@@ -18710,7 +18955,7 @@
         <p:spPr>
           <a:xfrm>
             <a:off x="0" y="658368"/>
-            <a:ext cx="5120640" cy="5833872"/>
+            <a:ext cx="3840480" cy="5833872"/>
           </a:xfrm>
           <a:prstGeom prst="rect">
             <a:avLst/>
@@ -18725,8 +18970,8 @@
         </p:nvSpPr>
         <p:spPr>
           <a:xfrm>
-            <a:off x="5349240" y="1005840"/>
-            <a:ext cx="6522415" cy="731520"/>
+            <a:off x="4069080" y="1005840"/>
+            <a:ext cx="7802575" cy="731520"/>
           </a:xfrm>
           <a:prstGeom prst="rect">
             <a:avLst/>
@@ -18752,7 +18997,7 @@
                 <a:ea typeface="Times New Roman" pitchFamily="34" charset="-122"/>
                 <a:cs typeface="Times New Roman" pitchFamily="34" charset="-120"/>
               </a:rPr>
-              <a:t>Expected Answer</a:t>
+              <a:t>4. Factors of Urban Climates</a:t>
             </a:r>
             <a:endParaRPr lang="en-US" sz="3600" dirty="0"/>
           </a:p>
@@ -18766,8 +19011,8 @@
         </p:nvSpPr>
         <p:spPr>
           <a:xfrm>
-            <a:off x="5349240" y="1783080"/>
-            <a:ext cx="6522415" cy="4663440"/>
+            <a:off x="4069080" y="1783080"/>
+            <a:ext cx="7802575" cy="4663440"/>
           </a:xfrm>
           <a:prstGeom prst="rect">
             <a:avLst/>
@@ -18786,7 +19031,7 @@
               <a:buNone/>
             </a:pPr>
             <a:r>
-              <a:rPr lang="en-US" sz="4000" dirty="0">
+              <a:rPr lang="en-US" sz="4000" b="1" dirty="0">
                 <a:solidFill>
                   <a:srgbClr val="111111"/>
                 </a:solidFill>
@@ -18794,7 +19039,24 @@
                 <a:ea typeface="Times New Roman" pitchFamily="34" charset="-122"/>
                 <a:cs typeface="Times New Roman" pitchFamily="34" charset="-120"/>
               </a:rPr>
-              <a:t>The town is warmer than the countryside; causes: tar and concrete, heat from vehicles and generators, few trees (any two).</a:t>
+              <a:t>Anthropogenic heat: </a:t>
+            </a:r>
+            <a:pPr algn="l" indent="0" marL="0">
+              <a:spcAft>
+                <a:spcPts val="800"/>
+              </a:spcAft>
+              <a:buNone/>
+            </a:pPr>
+            <a:r>
+              <a:rPr lang="en-US" sz="4000" dirty="0">
+                <a:solidFill>
+                  <a:srgbClr val="111111"/>
+                </a:solidFill>
+                <a:latin typeface="Times New Roman" pitchFamily="34" charset="0"/>
+                <a:ea typeface="Times New Roman" pitchFamily="34" charset="-122"/>
+                <a:cs typeface="Times New Roman" pitchFamily="34" charset="-120"/>
+              </a:rPr>
+              <a:t>Cars, moto-taxis, generators, air conditioners, factories and crowds all release heat. In big cities, this heat can equal a large part of the energy received from the sun in winter.</a:t>
             </a:r>
             <a:endParaRPr lang="en-US" sz="4000" dirty="0"/>
           </a:p>
@@ -18906,7 +19168,7 @@
                 <a:ea typeface="Calibri" pitchFamily="34" charset="-122"/>
                 <a:cs typeface="Calibri" pitchFamily="34" charset="-120"/>
               </a:rPr>
-              <a:t>FORMATIVE EVALUATION</a:t>
+              <a:t>BOARD SUMMARY</a:t>
             </a:r>
             <a:endParaRPr lang="en-US" sz="1400" dirty="0"/>
           </a:p>
@@ -18971,7 +19233,7 @@
                 <a:ea typeface="Times New Roman" pitchFamily="34" charset="-122"/>
                 <a:cs typeface="Times New Roman" pitchFamily="34" charset="-120"/>
               </a:rPr>
-              <a:t>Evaluation 2</a:t>
+              <a:t>4. Factors of Urban Climates</a:t>
             </a:r>
             <a:endParaRPr lang="en-US" sz="3600" dirty="0"/>
           </a:p>
@@ -19005,7 +19267,7 @@
               <a:buNone/>
             </a:pPr>
             <a:r>
-              <a:rPr lang="en-US" sz="4000" dirty="0">
+              <a:rPr lang="en-US" sz="4000" b="1" dirty="0">
                 <a:solidFill>
                   <a:srgbClr val="111111"/>
                 </a:solidFill>
@@ -19013,7 +19275,24 @@
                 <a:ea typeface="Times New Roman" pitchFamily="34" charset="-122"/>
                 <a:cs typeface="Times New Roman" pitchFamily="34" charset="-120"/>
               </a:rPr>
-              <a:t>Give two differences between an urban climate and a rural climate.</a:t>
+              <a:t>Reduced evapotranspiration: </a:t>
+            </a:r>
+            <a:pPr algn="l" indent="0" marL="0">
+              <a:spcAft>
+                <a:spcPts val="800"/>
+              </a:spcAft>
+              <a:buNone/>
+            </a:pPr>
+            <a:r>
+              <a:rPr lang="en-US" sz="4000" dirty="0">
+                <a:solidFill>
+                  <a:srgbClr val="111111"/>
+                </a:solidFill>
+                <a:latin typeface="Times New Roman" pitchFamily="34" charset="0"/>
+                <a:ea typeface="Times New Roman" pitchFamily="34" charset="-122"/>
+                <a:cs typeface="Times New Roman" pitchFamily="34" charset="-120"/>
+              </a:rPr>
+              <a:t>Towns have few trees, gardens and open soils. The energy that would be used to evaporate water is used instead to warm the air.</a:t>
             </a:r>
             <a:endParaRPr lang="en-US" sz="4000" dirty="0"/>
           </a:p>
@@ -19125,7 +19404,7 @@
                 <a:ea typeface="Calibri" pitchFamily="34" charset="-122"/>
                 <a:cs typeface="Calibri" pitchFamily="34" charset="-120"/>
               </a:rPr>
-              <a:t>FORMATIVE EVALUATION</a:t>
+              <a:t>BOARD SUMMARY</a:t>
             </a:r>
             <a:endParaRPr lang="en-US" sz="1400" dirty="0"/>
           </a:p>
@@ -19190,7 +19469,7 @@
                 <a:ea typeface="Times New Roman" pitchFamily="34" charset="-122"/>
                 <a:cs typeface="Times New Roman" pitchFamily="34" charset="-120"/>
               </a:rPr>
-              <a:t>Expected Answer</a:t>
+              <a:t>4. Factors of Urban Climates</a:t>
             </a:r>
             <a:endParaRPr lang="en-US" sz="3600" dirty="0"/>
           </a:p>
@@ -19224,7 +19503,7 @@
               <a:buNone/>
             </a:pPr>
             <a:r>
-              <a:rPr lang="en-US" sz="4000" dirty="0">
+              <a:rPr lang="en-US" sz="4000" b="1" dirty="0">
                 <a:solidFill>
                   <a:srgbClr val="111111"/>
                 </a:solidFill>
@@ -19232,7 +19511,24 @@
                 <a:ea typeface="Times New Roman" pitchFamily="34" charset="-122"/>
                 <a:cs typeface="Times New Roman" pitchFamily="34" charset="-120"/>
               </a:rPr>
-              <a:t>Towns are warmer, drier, less windy and more polluted (any two).</a:t>
+              <a:t>Urban geometry: </a:t>
+            </a:r>
+            <a:pPr algn="l" indent="0" marL="0">
+              <a:spcAft>
+                <a:spcPts val="800"/>
+              </a:spcAft>
+              <a:buNone/>
+            </a:pPr>
+            <a:r>
+              <a:rPr lang="en-US" sz="4000" dirty="0">
+                <a:solidFill>
+                  <a:srgbClr val="111111"/>
+                </a:solidFill>
+                <a:latin typeface="Times New Roman" pitchFamily="34" charset="0"/>
+                <a:ea typeface="Times New Roman" pitchFamily="34" charset="-122"/>
+                <a:cs typeface="Times New Roman" pitchFamily="34" charset="-120"/>
+              </a:rPr>
+              <a:t>Tall buildings and narrow streets form urban canyons that trap the heat radiated by walls and roads. They also block the wind that could carry this heat away.</a:t>
             </a:r>
             <a:endParaRPr lang="en-US" sz="4000" dirty="0"/>
           </a:p>
@@ -19344,7 +19640,7 @@
                 <a:ea typeface="Calibri" pitchFamily="34" charset="-122"/>
                 <a:cs typeface="Calibri" pitchFamily="34" charset="-120"/>
               </a:rPr>
-              <a:t>REMEDIATION</a:t>
+              <a:t>FORMATIVE EVALUATION</a:t>
             </a:r>
             <a:endParaRPr lang="en-US" sz="1400" dirty="0"/>
           </a:p>
@@ -19367,7 +19663,7 @@
         <p:spPr>
           <a:xfrm>
             <a:off x="0" y="658368"/>
-            <a:ext cx="1463040" cy="5833872"/>
+            <a:ext cx="5120640" cy="5833872"/>
           </a:xfrm>
           <a:prstGeom prst="rect">
             <a:avLst/>
@@ -19382,8 +19678,8 @@
         </p:nvSpPr>
         <p:spPr>
           <a:xfrm>
-            <a:off x="1691640" y="1005840"/>
-            <a:ext cx="10180015" cy="731520"/>
+            <a:off x="5349240" y="1005840"/>
+            <a:ext cx="6522415" cy="731520"/>
           </a:xfrm>
           <a:prstGeom prst="rect">
             <a:avLst/>
@@ -19409,7 +19705,7 @@
                 <a:ea typeface="Times New Roman" pitchFamily="34" charset="-122"/>
                 <a:cs typeface="Times New Roman" pitchFamily="34" charset="-120"/>
               </a:rPr>
-              <a:t>Remediation</a:t>
+              <a:t>Evaluation 1</a:t>
             </a:r>
             <a:endParaRPr lang="en-US" sz="3600" dirty="0"/>
           </a:p>
@@ -19423,8 +19719,8 @@
         </p:nvSpPr>
         <p:spPr>
           <a:xfrm>
-            <a:off x="1691640" y="1783080"/>
-            <a:ext cx="10180015" cy="4663440"/>
+            <a:off x="5349240" y="1783080"/>
+            <a:ext cx="6522415" cy="4663440"/>
           </a:xfrm>
           <a:prstGeom prst="rect">
             <a:avLst/>
@@ -19443,7 +19739,7 @@
               <a:buNone/>
             </a:pPr>
             <a:r>
-              <a:rPr lang="en-US" sz="4000" b="1" dirty="0">
+              <a:rPr lang="en-US" sz="4000" dirty="0">
                 <a:solidFill>
                   <a:srgbClr val="111111"/>
                 </a:solidFill>
@@ -19451,73 +19747,7 @@
                 <a:ea typeface="Times New Roman" pitchFamily="34" charset="-122"/>
                 <a:cs typeface="Times New Roman" pitchFamily="34" charset="-120"/>
               </a:rPr>
-              <a:t>Fill in the blanks:</a:t>
-            </a:r>
-            <a:endParaRPr lang="en-US" sz="4000" dirty="0"/>
-          </a:p>
-          <a:p>
-            <a:pPr algn="l" marL="342900" indent="-342900">
-              <a:spcAft>
-                <a:spcPts val="800"/>
-              </a:spcAft>
-              <a:buSzPct val="100000"/>
-              <a:buFont typeface="+mj-lt"/>
-              <a:buAutoNum type="arabicPeriod" startAt="1"/>
-            </a:pPr>
-            <a:r>
-              <a:rPr lang="en-US" sz="4000" dirty="0">
-                <a:solidFill>
-                  <a:srgbClr val="111111"/>
-                </a:solidFill>
-                <a:latin typeface="Times New Roman" pitchFamily="34" charset="0"/>
-                <a:ea typeface="Times New Roman" pitchFamily="34" charset="-122"/>
-                <a:cs typeface="Times New Roman" pitchFamily="34" charset="-120"/>
-              </a:rPr>
-              <a:t>The climate of a small area is a ______.</a:t>
-            </a:r>
-            <a:endParaRPr lang="en-US" sz="4000" dirty="0"/>
-          </a:p>
-          <a:p>
-            <a:pPr algn="l" marL="342900" indent="-342900">
-              <a:spcAft>
-                <a:spcPts val="800"/>
-              </a:spcAft>
-              <a:buSzPct val="100000"/>
-              <a:buFont typeface="+mj-lt"/>
-              <a:buAutoNum type="arabicPeriod" startAt="1"/>
-            </a:pPr>
-            <a:r>
-              <a:rPr lang="en-US" sz="4000" dirty="0">
-                <a:solidFill>
-                  <a:srgbClr val="111111"/>
-                </a:solidFill>
-                <a:latin typeface="Times New Roman" pitchFamily="34" charset="0"/>
-                <a:ea typeface="Times New Roman" pitchFamily="34" charset="-122"/>
-                <a:cs typeface="Times New Roman" pitchFamily="34" charset="-120"/>
-              </a:rPr>
-              <a:t>A town warmer than the countryside is an urban heat ______.</a:t>
-            </a:r>
-            <a:endParaRPr lang="en-US" sz="4000" dirty="0"/>
-          </a:p>
-          <a:p>
-            <a:pPr algn="l" marL="342900" indent="-342900">
-              <a:spcAft>
-                <a:spcPts val="800"/>
-              </a:spcAft>
-              <a:buSzPct val="100000"/>
-              <a:buFont typeface="+mj-lt"/>
-              <a:buAutoNum type="arabicPeriod" startAt="1"/>
-            </a:pPr>
-            <a:r>
-              <a:rPr lang="en-US" sz="4000" dirty="0">
-                <a:solidFill>
-                  <a:srgbClr val="111111"/>
-                </a:solidFill>
-                <a:latin typeface="Times New Roman" pitchFamily="34" charset="0"/>
-                <a:ea typeface="Times New Roman" pitchFamily="34" charset="-122"/>
-                <a:cs typeface="Times New Roman" pitchFamily="34" charset="-120"/>
-              </a:rPr>
-              <a:t>Heat from vehicles and machines is ______ heat.</a:t>
+              <a:t>What is the urban heat island, and give two of its causes in Garoua?</a:t>
             </a:r>
             <a:endParaRPr lang="en-US" sz="4000" dirty="0"/>
           </a:p>
@@ -19629,7 +19859,7 @@
                 <a:ea typeface="Calibri" pitchFamily="34" charset="-122"/>
                 <a:cs typeface="Calibri" pitchFamily="34" charset="-120"/>
               </a:rPr>
-              <a:t>HOMEWORK</a:t>
+              <a:t>FORMATIVE EVALUATION</a:t>
             </a:r>
             <a:endParaRPr lang="en-US" sz="1400" dirty="0"/>
           </a:p>
@@ -19694,7 +19924,7 @@
                 <a:ea typeface="Times New Roman" pitchFamily="34" charset="-122"/>
                 <a:cs typeface="Times New Roman" pitchFamily="34" charset="-120"/>
               </a:rPr>
-              <a:t>Homework</a:t>
+              <a:t>Expected Answer</a:t>
             </a:r>
             <a:endParaRPr lang="en-US" sz="3600" dirty="0"/>
           </a:p>
@@ -19736,7 +19966,7 @@
                 <a:ea typeface="Times New Roman" pitchFamily="34" charset="-122"/>
                 <a:cs typeface="Times New Roman" pitchFamily="34" charset="-120"/>
               </a:rPr>
-              <a:t>State how temperature changes with altitude.</a:t>
+              <a:t>The town is warmer than the countryside; causes: tar and concrete, heat from vehicles and generators, few trees (any two).</a:t>
             </a:r>
             <a:endParaRPr lang="en-US" sz="4000" dirty="0"/>
           </a:p>
@@ -19848,7 +20078,7 @@
                 <a:ea typeface="Calibri" pitchFamily="34" charset="-122"/>
                 <a:cs typeface="Calibri" pitchFamily="34" charset="-120"/>
               </a:rPr>
-              <a:t>NEXT LESSON</a:t>
+              <a:t>FORMATIVE EVALUATION</a:t>
             </a:r>
             <a:endParaRPr lang="en-US" sz="1400" dirty="0"/>
           </a:p>
@@ -19913,7 +20143,7 @@
                 <a:ea typeface="Times New Roman" pitchFamily="34" charset="-122"/>
                 <a:cs typeface="Times New Roman" pitchFamily="34" charset="-120"/>
               </a:rPr>
-              <a:t>Next Lesson</a:t>
+              <a:t>Evaluation 2</a:t>
             </a:r>
             <a:endParaRPr lang="en-US" sz="3600" dirty="0"/>
           </a:p>
@@ -19937,17 +20167,17 @@
           <a:ln/>
         </p:spPr>
         <p:txBody>
-          <a:bodyPr wrap="square" lIns="0" tIns="0" rIns="0" bIns="0" rtlCol="0" anchor="ctr"/>
-          <a:lstStyle/>
-          <a:p>
-            <a:pPr algn="ctr" indent="0" marL="0">
+          <a:bodyPr wrap="square" lIns="0" tIns="0" rIns="0" bIns="0" rtlCol="0" anchor="t"/>
+          <a:lstStyle/>
+          <a:p>
+            <a:pPr algn="l" indent="0" marL="0">
               <a:spcAft>
                 <a:spcPts val="800"/>
               </a:spcAft>
               <a:buNone/>
             </a:pPr>
             <a:r>
-              <a:rPr lang="en-US" sz="4000" b="1" dirty="0">
+              <a:rPr lang="en-US" sz="4000" dirty="0">
                 <a:solidFill>
                   <a:srgbClr val="111111"/>
                 </a:solidFill>
@@ -19955,27 +20185,7 @@
                 <a:ea typeface="Times New Roman" pitchFamily="34" charset="-122"/>
                 <a:cs typeface="Times New Roman" pitchFamily="34" charset="-120"/>
               </a:rPr>
-              <a:t>Our next lesson will be on:</a:t>
-            </a:r>
-            <a:endParaRPr lang="en-US" sz="4000" dirty="0"/>
-          </a:p>
-          <a:p>
-            <a:pPr algn="ctr" indent="0" marL="0">
-              <a:spcAft>
-                <a:spcPts val="800"/>
-              </a:spcAft>
-              <a:buNone/>
-            </a:pPr>
-            <a:r>
-              <a:rPr lang="en-US" sz="4000" b="1" dirty="0">
-                <a:solidFill>
-                  <a:srgbClr val="990011"/>
-                </a:solidFill>
-                <a:latin typeface="Times New Roman" pitchFamily="34" charset="0"/>
-                <a:ea typeface="Times New Roman" pitchFamily="34" charset="-122"/>
-                <a:cs typeface="Times New Roman" pitchFamily="34" charset="-120"/>
-              </a:rPr>
-              <a:t>Lesson 21: Mountain Climates</a:t>
+              <a:t>Give two differences between an urban climate and a rural climate.</a:t>
             </a:r>
             <a:endParaRPr lang="en-US" sz="4000" dirty="0"/>
           </a:p>
@@ -20087,6 +20297,1299 @@
                 <a:ea typeface="Calibri" pitchFamily="34" charset="-122"/>
                 <a:cs typeface="Calibri" pitchFamily="34" charset="-120"/>
               </a:rPr>
+              <a:t>FORMATIVE EVALUATION</a:t>
+            </a:r>
+            <a:endParaRPr lang="en-US" sz="1400" dirty="0"/>
+          </a:p>
+        </p:txBody>
+      </p:sp>
+      <p:pic>
+        <p:nvPicPr>
+          <p:cNvPr id="3" name="Image 0" descr="/home/claude/f4/img/minesec_sheet.png">    </p:cNvPr>
+          <p:cNvPicPr>
+            <a:picLocks noChangeAspect="1"/>
+          </p:cNvPicPr>
+          <p:nvPr/>
+        </p:nvPicPr>
+        <p:blipFill>
+          <a:blip r:embed="rId1"/>
+          <a:stretch>
+            <a:fillRect/>
+          </a:stretch>
+        </p:blipFill>
+        <p:spPr>
+          <a:xfrm>
+            <a:off x="0" y="658368"/>
+            <a:ext cx="5120640" cy="5833872"/>
+          </a:xfrm>
+          <a:prstGeom prst="rect">
+            <a:avLst/>
+          </a:prstGeom>
+        </p:spPr>
+      </p:pic>
+      <p:sp>
+        <p:nvSpPr>
+          <p:cNvPr id="4" name="Text 1"/>
+          <p:cNvSpPr/>
+          <p:nvPr/>
+        </p:nvSpPr>
+        <p:spPr>
+          <a:xfrm>
+            <a:off x="5349240" y="1005840"/>
+            <a:ext cx="6522415" cy="731520"/>
+          </a:xfrm>
+          <a:prstGeom prst="rect">
+            <a:avLst/>
+          </a:prstGeom>
+          <a:noFill/>
+          <a:ln/>
+        </p:spPr>
+        <p:txBody>
+          <a:bodyPr wrap="square" lIns="0" tIns="0" rIns="0" bIns="0" rtlCol="0" anchor="ctr">
+            <a:normAutofit/>
+          </a:bodyPr>
+          <a:lstStyle/>
+          <a:p>
+            <a:pPr algn="ctr" indent="0" marL="0">
+              <a:buNone/>
+            </a:pPr>
+            <a:r>
+              <a:rPr lang="en-US" sz="3600" b="1" dirty="0">
+                <a:solidFill>
+                  <a:srgbClr val="990011"/>
+                </a:solidFill>
+                <a:latin typeface="Times New Roman" pitchFamily="34" charset="0"/>
+                <a:ea typeface="Times New Roman" pitchFamily="34" charset="-122"/>
+                <a:cs typeface="Times New Roman" pitchFamily="34" charset="-120"/>
+              </a:rPr>
+              <a:t>Expected Answer</a:t>
+            </a:r>
+            <a:endParaRPr lang="en-US" sz="3600" dirty="0"/>
+          </a:p>
+        </p:txBody>
+      </p:sp>
+      <p:sp>
+        <p:nvSpPr>
+          <p:cNvPr id="5" name="Text 2"/>
+          <p:cNvSpPr/>
+          <p:nvPr/>
+        </p:nvSpPr>
+        <p:spPr>
+          <a:xfrm>
+            <a:off x="5349240" y="1783080"/>
+            <a:ext cx="6522415" cy="4663440"/>
+          </a:xfrm>
+          <a:prstGeom prst="rect">
+            <a:avLst/>
+          </a:prstGeom>
+          <a:noFill/>
+          <a:ln/>
+        </p:spPr>
+        <p:txBody>
+          <a:bodyPr wrap="square" lIns="0" tIns="0" rIns="0" bIns="0" rtlCol="0" anchor="t"/>
+          <a:lstStyle/>
+          <a:p>
+            <a:pPr algn="l" indent="0" marL="0">
+              <a:spcAft>
+                <a:spcPts val="800"/>
+              </a:spcAft>
+              <a:buNone/>
+            </a:pPr>
+            <a:r>
+              <a:rPr lang="en-US" sz="4000" dirty="0">
+                <a:solidFill>
+                  <a:srgbClr val="111111"/>
+                </a:solidFill>
+                <a:latin typeface="Times New Roman" pitchFamily="34" charset="0"/>
+                <a:ea typeface="Times New Roman" pitchFamily="34" charset="-122"/>
+                <a:cs typeface="Times New Roman" pitchFamily="34" charset="-120"/>
+              </a:rPr>
+              <a:t>Towns are warmer, drier, less windy and more polluted (any two).</a:t>
+            </a:r>
+            <a:endParaRPr lang="en-US" sz="4000" dirty="0"/>
+          </a:p>
+        </p:txBody>
+      </p:sp>
+      <p:sp>
+        <p:nvSpPr>
+          <p:cNvPr id="25" name="Slide Number Placeholder 0"/>
+          <p:cNvSpPr>
+            <a:spLocks noGrp="1"/>
+          </p:cNvSpPr>
+          <p:nvPr>
+            <p:ph type="sldNum" sz="quarter" idx="4294967295"/>
+          </p:nvPr>
+        </p:nvSpPr>
+        <p:spPr>
+          <a:xfrm>
+            <a:off x="27432" y="91440"/>
+            <a:ext cx="585216" cy="475488"/>
+          </a:xfrm>
+          <a:prstGeom prst="rect">
+            <a:avLst/>
+          </a:prstGeom>
+          <a:extLst>
+            <a:ext uri="{C572A759-6A51-4108-AA02-DFA0A04FC94B}">
+              <ma14:wrappingTextBoxFlag xmlns:ma14="http://schemas.microsoft.com/office/mac/drawingml/2011/main" val="0"/>
+            </a:ext>
+          </a:extLst>
+        </p:spPr>
+        <p:txBody>
+          <a:bodyPr/>
+          <a:lstStyle>
+            <a:lvl1pPr>
+              <a:defRPr sz="2000">
+                <a:solidFill>
+                  <a:srgbClr val="FFFFFF"/>
+                </a:solidFill>
+                <a:latin typeface="Calibri"/>
+                <a:ea typeface="Calibri"/>
+                <a:cs typeface="Calibri"/>
+              </a:defRPr>
+            </a:lvl1pPr>
+          </a:lstStyle>
+          <a:p>
+            <a:pPr algn="ctr"/>
+            <a:fld id="{F7021451-1387-4CA6-816F-3879F97B5CBC}" type="slidenum">
+              <a:rPr b="1" lang="en-US"/>
+              <a:t>56</a:t>
+            </a:fld>
+            <a:endParaRPr lang="en-US"/>
+          </a:p>
+        </p:txBody>
+      </p:sp>
+    </p:spTree>
+  </p:cSld>
+  <p:clrMapOvr>
+    <a:masterClrMapping/>
+  </p:clrMapOvr>
+</p:sld>
+</file>
+
+<file path=ppt/slides/slide57.xml><?xml version="1.0" encoding="utf-8"?>
+<p:sld xmlns:a="http://schemas.openxmlformats.org/drawingml/2006/main" xmlns:r="http://schemas.openxmlformats.org/officeDocument/2006/relationships" xmlns:p="http://schemas.openxmlformats.org/presentationml/2006/main">
+  <p:cSld name="Slide 57">
+    <p:spTree>
+      <p:nvGrpSpPr>
+        <p:cNvPr id="1" name=""/>
+        <p:cNvGrpSpPr/>
+        <p:nvPr/>
+      </p:nvGrpSpPr>
+      <p:grpSpPr>
+        <a:xfrm>
+          <a:off x="0" y="0"/>
+          <a:ext cx="0" cy="0"/>
+          <a:chOff x="0" y="0"/>
+          <a:chExt cx="0" cy="0"/>
+        </a:xfrm>
+      </p:grpSpPr>
+      <p:sp>
+        <p:nvSpPr>
+          <p:cNvPr id="2" name="Text 0"/>
+          <p:cNvSpPr/>
+          <p:nvPr/>
+        </p:nvSpPr>
+        <p:spPr>
+          <a:xfrm>
+            <a:off x="457200" y="713232"/>
+            <a:ext cx="11368735" cy="274320"/>
+          </a:xfrm>
+          <a:prstGeom prst="rect">
+            <a:avLst/>
+          </a:prstGeom>
+          <a:noFill/>
+          <a:ln/>
+        </p:spPr>
+        <p:txBody>
+          <a:bodyPr wrap="square" lIns="0" tIns="0" rIns="0" bIns="0" rtlCol="0" anchor="ctr"/>
+          <a:lstStyle/>
+          <a:p>
+            <a:pPr algn="r" indent="0" marL="0">
+              <a:buNone/>
+            </a:pPr>
+            <a:r>
+              <a:rPr lang="en-US" sz="1400" b="1" dirty="0">
+                <a:solidFill>
+                  <a:srgbClr val="1C3F6E"/>
+                </a:solidFill>
+                <a:latin typeface="Calibri" pitchFamily="34" charset="0"/>
+                <a:ea typeface="Calibri" pitchFamily="34" charset="-122"/>
+                <a:cs typeface="Calibri" pitchFamily="34" charset="-120"/>
+              </a:rPr>
+              <a:t>REMEDIATION</a:t>
+            </a:r>
+            <a:endParaRPr lang="en-US" sz="1400" dirty="0"/>
+          </a:p>
+        </p:txBody>
+      </p:sp>
+      <p:pic>
+        <p:nvPicPr>
+          <p:cNvPr id="3" name="Image 0" descr="/home/claude/f4/img/minesec_sheet.png">    </p:cNvPr>
+          <p:cNvPicPr>
+            <a:picLocks noChangeAspect="1"/>
+          </p:cNvPicPr>
+          <p:nvPr/>
+        </p:nvPicPr>
+        <p:blipFill>
+          <a:blip r:embed="rId1"/>
+          <a:stretch>
+            <a:fillRect/>
+          </a:stretch>
+        </p:blipFill>
+        <p:spPr>
+          <a:xfrm>
+            <a:off x="0" y="658368"/>
+            <a:ext cx="1463040" cy="5833872"/>
+          </a:xfrm>
+          <a:prstGeom prst="rect">
+            <a:avLst/>
+          </a:prstGeom>
+        </p:spPr>
+      </p:pic>
+      <p:sp>
+        <p:nvSpPr>
+          <p:cNvPr id="4" name="Text 1"/>
+          <p:cNvSpPr/>
+          <p:nvPr/>
+        </p:nvSpPr>
+        <p:spPr>
+          <a:xfrm>
+            <a:off x="1691640" y="1005840"/>
+            <a:ext cx="10180015" cy="731520"/>
+          </a:xfrm>
+          <a:prstGeom prst="rect">
+            <a:avLst/>
+          </a:prstGeom>
+          <a:noFill/>
+          <a:ln/>
+        </p:spPr>
+        <p:txBody>
+          <a:bodyPr wrap="square" lIns="0" tIns="0" rIns="0" bIns="0" rtlCol="0" anchor="ctr">
+            <a:normAutofit/>
+          </a:bodyPr>
+          <a:lstStyle/>
+          <a:p>
+            <a:pPr algn="ctr" indent="0" marL="0">
+              <a:buNone/>
+            </a:pPr>
+            <a:r>
+              <a:rPr lang="en-US" sz="3600" b="1" dirty="0">
+                <a:solidFill>
+                  <a:srgbClr val="990011"/>
+                </a:solidFill>
+                <a:latin typeface="Times New Roman" pitchFamily="34" charset="0"/>
+                <a:ea typeface="Times New Roman" pitchFamily="34" charset="-122"/>
+                <a:cs typeface="Times New Roman" pitchFamily="34" charset="-120"/>
+              </a:rPr>
+              <a:t>Remediation</a:t>
+            </a:r>
+            <a:endParaRPr lang="en-US" sz="3600" dirty="0"/>
+          </a:p>
+        </p:txBody>
+      </p:sp>
+      <p:sp>
+        <p:nvSpPr>
+          <p:cNvPr id="5" name="Text 2"/>
+          <p:cNvSpPr/>
+          <p:nvPr/>
+        </p:nvSpPr>
+        <p:spPr>
+          <a:xfrm>
+            <a:off x="1691640" y="1783080"/>
+            <a:ext cx="10180015" cy="4663440"/>
+          </a:xfrm>
+          <a:prstGeom prst="rect">
+            <a:avLst/>
+          </a:prstGeom>
+          <a:noFill/>
+          <a:ln/>
+        </p:spPr>
+        <p:txBody>
+          <a:bodyPr wrap="square" lIns="0" tIns="0" rIns="0" bIns="0" rtlCol="0" anchor="t"/>
+          <a:lstStyle/>
+          <a:p>
+            <a:pPr algn="l" indent="0" marL="0">
+              <a:spcAft>
+                <a:spcPts val="800"/>
+              </a:spcAft>
+              <a:buNone/>
+            </a:pPr>
+            <a:r>
+              <a:rPr lang="en-US" sz="4000" b="1" dirty="0">
+                <a:solidFill>
+                  <a:srgbClr val="111111"/>
+                </a:solidFill>
+                <a:latin typeface="Times New Roman" pitchFamily="34" charset="0"/>
+                <a:ea typeface="Times New Roman" pitchFamily="34" charset="-122"/>
+                <a:cs typeface="Times New Roman" pitchFamily="34" charset="-120"/>
+              </a:rPr>
+              <a:t>Fill in the blanks:</a:t>
+            </a:r>
+            <a:endParaRPr lang="en-US" sz="4000" dirty="0"/>
+          </a:p>
+          <a:p>
+            <a:pPr algn="l" marL="342900" indent="-342900">
+              <a:spcAft>
+                <a:spcPts val="800"/>
+              </a:spcAft>
+              <a:buSzPct val="100000"/>
+              <a:buFont typeface="+mj-lt"/>
+              <a:buAutoNum type="arabicPeriod" startAt="1"/>
+            </a:pPr>
+            <a:r>
+              <a:rPr lang="en-US" sz="4000" dirty="0">
+                <a:solidFill>
+                  <a:srgbClr val="111111"/>
+                </a:solidFill>
+                <a:latin typeface="Times New Roman" pitchFamily="34" charset="0"/>
+                <a:ea typeface="Times New Roman" pitchFamily="34" charset="-122"/>
+                <a:cs typeface="Times New Roman" pitchFamily="34" charset="-120"/>
+              </a:rPr>
+              <a:t>The climate of a small area is a ______.</a:t>
+            </a:r>
+            <a:endParaRPr lang="en-US" sz="4000" dirty="0"/>
+          </a:p>
+          <a:p>
+            <a:pPr algn="l" marL="342900" indent="-342900">
+              <a:spcAft>
+                <a:spcPts val="800"/>
+              </a:spcAft>
+              <a:buSzPct val="100000"/>
+              <a:buFont typeface="+mj-lt"/>
+              <a:buAutoNum type="arabicPeriod" startAt="1"/>
+            </a:pPr>
+            <a:r>
+              <a:rPr lang="en-US" sz="4000" dirty="0">
+                <a:solidFill>
+                  <a:srgbClr val="111111"/>
+                </a:solidFill>
+                <a:latin typeface="Times New Roman" pitchFamily="34" charset="0"/>
+                <a:ea typeface="Times New Roman" pitchFamily="34" charset="-122"/>
+                <a:cs typeface="Times New Roman" pitchFamily="34" charset="-120"/>
+              </a:rPr>
+              <a:t>A town warmer than the countryside is an urban heat ______.</a:t>
+            </a:r>
+            <a:endParaRPr lang="en-US" sz="4000" dirty="0"/>
+          </a:p>
+          <a:p>
+            <a:pPr algn="l" marL="342900" indent="-342900">
+              <a:spcAft>
+                <a:spcPts val="800"/>
+              </a:spcAft>
+              <a:buSzPct val="100000"/>
+              <a:buFont typeface="+mj-lt"/>
+              <a:buAutoNum type="arabicPeriod" startAt="1"/>
+            </a:pPr>
+            <a:r>
+              <a:rPr lang="en-US" sz="4000" dirty="0">
+                <a:solidFill>
+                  <a:srgbClr val="111111"/>
+                </a:solidFill>
+                <a:latin typeface="Times New Roman" pitchFamily="34" charset="0"/>
+                <a:ea typeface="Times New Roman" pitchFamily="34" charset="-122"/>
+                <a:cs typeface="Times New Roman" pitchFamily="34" charset="-120"/>
+              </a:rPr>
+              <a:t>Heat from vehicles and machines is ______ heat.</a:t>
+            </a:r>
+            <a:endParaRPr lang="en-US" sz="4000" dirty="0"/>
+          </a:p>
+        </p:txBody>
+      </p:sp>
+      <p:sp>
+        <p:nvSpPr>
+          <p:cNvPr id="25" name="Slide Number Placeholder 0"/>
+          <p:cNvSpPr>
+            <a:spLocks noGrp="1"/>
+          </p:cNvSpPr>
+          <p:nvPr>
+            <p:ph type="sldNum" sz="quarter" idx="4294967295"/>
+          </p:nvPr>
+        </p:nvSpPr>
+        <p:spPr>
+          <a:xfrm>
+            <a:off x="27432" y="91440"/>
+            <a:ext cx="585216" cy="475488"/>
+          </a:xfrm>
+          <a:prstGeom prst="rect">
+            <a:avLst/>
+          </a:prstGeom>
+          <a:extLst>
+            <a:ext uri="{C572A759-6A51-4108-AA02-DFA0A04FC94B}">
+              <ma14:wrappingTextBoxFlag xmlns:ma14="http://schemas.microsoft.com/office/mac/drawingml/2011/main" val="0"/>
+            </a:ext>
+          </a:extLst>
+        </p:spPr>
+        <p:txBody>
+          <a:bodyPr/>
+          <a:lstStyle>
+            <a:lvl1pPr>
+              <a:defRPr sz="2000">
+                <a:solidFill>
+                  <a:srgbClr val="FFFFFF"/>
+                </a:solidFill>
+                <a:latin typeface="Calibri"/>
+                <a:ea typeface="Calibri"/>
+                <a:cs typeface="Calibri"/>
+              </a:defRPr>
+            </a:lvl1pPr>
+          </a:lstStyle>
+          <a:p>
+            <a:pPr algn="ctr"/>
+            <a:fld id="{F7021451-1387-4CA6-816F-3879F97B5CBC}" type="slidenum">
+              <a:rPr b="1" lang="en-US"/>
+              <a:t>57</a:t>
+            </a:fld>
+            <a:endParaRPr lang="en-US"/>
+          </a:p>
+        </p:txBody>
+      </p:sp>
+    </p:spTree>
+  </p:cSld>
+  <p:clrMapOvr>
+    <a:masterClrMapping/>
+  </p:clrMapOvr>
+</p:sld>
+</file>
+
+<file path=ppt/slides/slide58.xml><?xml version="1.0" encoding="utf-8"?>
+<p:sld xmlns:a="http://schemas.openxmlformats.org/drawingml/2006/main" xmlns:r="http://schemas.openxmlformats.org/officeDocument/2006/relationships" xmlns:p="http://schemas.openxmlformats.org/presentationml/2006/main">
+  <p:cSld name="Slide 58">
+    <p:spTree>
+      <p:nvGrpSpPr>
+        <p:cNvPr id="1" name=""/>
+        <p:cNvGrpSpPr/>
+        <p:nvPr/>
+      </p:nvGrpSpPr>
+      <p:grpSpPr>
+        <a:xfrm>
+          <a:off x="0" y="0"/>
+          <a:ext cx="0" cy="0"/>
+          <a:chOff x="0" y="0"/>
+          <a:chExt cx="0" cy="0"/>
+        </a:xfrm>
+      </p:grpSpPr>
+      <p:sp>
+        <p:nvSpPr>
+          <p:cNvPr id="2" name="Text 0"/>
+          <p:cNvSpPr/>
+          <p:nvPr/>
+        </p:nvSpPr>
+        <p:spPr>
+          <a:xfrm>
+            <a:off x="457200" y="713232"/>
+            <a:ext cx="11368735" cy="274320"/>
+          </a:xfrm>
+          <a:prstGeom prst="rect">
+            <a:avLst/>
+          </a:prstGeom>
+          <a:noFill/>
+          <a:ln/>
+        </p:spPr>
+        <p:txBody>
+          <a:bodyPr wrap="square" lIns="0" tIns="0" rIns="0" bIns="0" rtlCol="0" anchor="ctr"/>
+          <a:lstStyle/>
+          <a:p>
+            <a:pPr algn="r" indent="0" marL="0">
+              <a:buNone/>
+            </a:pPr>
+            <a:r>
+              <a:rPr lang="en-US" sz="1400" b="1" dirty="0">
+                <a:solidFill>
+                  <a:srgbClr val="1C3F6E"/>
+                </a:solidFill>
+                <a:latin typeface="Calibri" pitchFamily="34" charset="0"/>
+                <a:ea typeface="Calibri" pitchFamily="34" charset="-122"/>
+                <a:cs typeface="Calibri" pitchFamily="34" charset="-120"/>
+              </a:rPr>
+              <a:t>HOMEWORK</a:t>
+            </a:r>
+            <a:endParaRPr lang="en-US" sz="1400" dirty="0"/>
+          </a:p>
+        </p:txBody>
+      </p:sp>
+      <p:pic>
+        <p:nvPicPr>
+          <p:cNvPr id="3" name="Image 0" descr="/home/claude/f4/img/minesec_sheet.png">    </p:cNvPr>
+          <p:cNvPicPr>
+            <a:picLocks noChangeAspect="1"/>
+          </p:cNvPicPr>
+          <p:nvPr/>
+        </p:nvPicPr>
+        <p:blipFill>
+          <a:blip r:embed="rId1"/>
+          <a:stretch>
+            <a:fillRect/>
+          </a:stretch>
+        </p:blipFill>
+        <p:spPr>
+          <a:xfrm>
+            <a:off x="0" y="658368"/>
+            <a:ext cx="5120640" cy="5833872"/>
+          </a:xfrm>
+          <a:prstGeom prst="rect">
+            <a:avLst/>
+          </a:prstGeom>
+        </p:spPr>
+      </p:pic>
+      <p:sp>
+        <p:nvSpPr>
+          <p:cNvPr id="4" name="Text 1"/>
+          <p:cNvSpPr/>
+          <p:nvPr/>
+        </p:nvSpPr>
+        <p:spPr>
+          <a:xfrm>
+            <a:off x="5349240" y="1005840"/>
+            <a:ext cx="6522415" cy="731520"/>
+          </a:xfrm>
+          <a:prstGeom prst="rect">
+            <a:avLst/>
+          </a:prstGeom>
+          <a:noFill/>
+          <a:ln/>
+        </p:spPr>
+        <p:txBody>
+          <a:bodyPr wrap="square" lIns="0" tIns="0" rIns="0" bIns="0" rtlCol="0" anchor="ctr">
+            <a:normAutofit/>
+          </a:bodyPr>
+          <a:lstStyle/>
+          <a:p>
+            <a:pPr algn="ctr" indent="0" marL="0">
+              <a:buNone/>
+            </a:pPr>
+            <a:r>
+              <a:rPr lang="en-US" sz="3600" b="1" dirty="0">
+                <a:solidFill>
+                  <a:srgbClr val="990011"/>
+                </a:solidFill>
+                <a:latin typeface="Times New Roman" pitchFamily="34" charset="0"/>
+                <a:ea typeface="Times New Roman" pitchFamily="34" charset="-122"/>
+                <a:cs typeface="Times New Roman" pitchFamily="34" charset="-120"/>
+              </a:rPr>
+              <a:t>Homework</a:t>
+            </a:r>
+            <a:endParaRPr lang="en-US" sz="3600" dirty="0"/>
+          </a:p>
+        </p:txBody>
+      </p:sp>
+      <p:sp>
+        <p:nvSpPr>
+          <p:cNvPr id="5" name="Text 2"/>
+          <p:cNvSpPr/>
+          <p:nvPr/>
+        </p:nvSpPr>
+        <p:spPr>
+          <a:xfrm>
+            <a:off x="5349240" y="1783080"/>
+            <a:ext cx="6522415" cy="4663440"/>
+          </a:xfrm>
+          <a:prstGeom prst="rect">
+            <a:avLst/>
+          </a:prstGeom>
+          <a:noFill/>
+          <a:ln/>
+        </p:spPr>
+        <p:txBody>
+          <a:bodyPr wrap="square" lIns="0" tIns="0" rIns="0" bIns="0" rtlCol="0" anchor="t"/>
+          <a:lstStyle/>
+          <a:p>
+            <a:pPr algn="l" indent="0" marL="0">
+              <a:spcAft>
+                <a:spcPts val="800"/>
+              </a:spcAft>
+              <a:buNone/>
+            </a:pPr>
+            <a:r>
+              <a:rPr lang="en-US" sz="4000" dirty="0">
+                <a:solidFill>
+                  <a:srgbClr val="111111"/>
+                </a:solidFill>
+                <a:latin typeface="Times New Roman" pitchFamily="34" charset="0"/>
+                <a:ea typeface="Times New Roman" pitchFamily="34" charset="-122"/>
+                <a:cs typeface="Times New Roman" pitchFamily="34" charset="-120"/>
+              </a:rPr>
+              <a:t>State how temperature changes with altitude.</a:t>
+            </a:r>
+            <a:endParaRPr lang="en-US" sz="4000" dirty="0"/>
+          </a:p>
+        </p:txBody>
+      </p:sp>
+      <p:sp>
+        <p:nvSpPr>
+          <p:cNvPr id="25" name="Slide Number Placeholder 0"/>
+          <p:cNvSpPr>
+            <a:spLocks noGrp="1"/>
+          </p:cNvSpPr>
+          <p:nvPr>
+            <p:ph type="sldNum" sz="quarter" idx="4294967295"/>
+          </p:nvPr>
+        </p:nvSpPr>
+        <p:spPr>
+          <a:xfrm>
+            <a:off x="27432" y="91440"/>
+            <a:ext cx="585216" cy="475488"/>
+          </a:xfrm>
+          <a:prstGeom prst="rect">
+            <a:avLst/>
+          </a:prstGeom>
+          <a:extLst>
+            <a:ext uri="{C572A759-6A51-4108-AA02-DFA0A04FC94B}">
+              <ma14:wrappingTextBoxFlag xmlns:ma14="http://schemas.microsoft.com/office/mac/drawingml/2011/main" val="0"/>
+            </a:ext>
+          </a:extLst>
+        </p:spPr>
+        <p:txBody>
+          <a:bodyPr/>
+          <a:lstStyle>
+            <a:lvl1pPr>
+              <a:defRPr sz="2000">
+                <a:solidFill>
+                  <a:srgbClr val="FFFFFF"/>
+                </a:solidFill>
+                <a:latin typeface="Calibri"/>
+                <a:ea typeface="Calibri"/>
+                <a:cs typeface="Calibri"/>
+              </a:defRPr>
+            </a:lvl1pPr>
+          </a:lstStyle>
+          <a:p>
+            <a:pPr algn="ctr"/>
+            <a:fld id="{F7021451-1387-4CA6-816F-3879F97B5CBC}" type="slidenum">
+              <a:rPr b="1" lang="en-US"/>
+              <a:t>58</a:t>
+            </a:fld>
+            <a:endParaRPr lang="en-US"/>
+          </a:p>
+        </p:txBody>
+      </p:sp>
+    </p:spTree>
+  </p:cSld>
+  <p:clrMapOvr>
+    <a:masterClrMapping/>
+  </p:clrMapOvr>
+</p:sld>
+</file>
+
+<file path=ppt/slides/slide59.xml><?xml version="1.0" encoding="utf-8"?>
+<p:sld xmlns:a="http://schemas.openxmlformats.org/drawingml/2006/main" xmlns:r="http://schemas.openxmlformats.org/officeDocument/2006/relationships" xmlns:p="http://schemas.openxmlformats.org/presentationml/2006/main">
+  <p:cSld name="Slide 59">
+    <p:spTree>
+      <p:nvGrpSpPr>
+        <p:cNvPr id="1" name=""/>
+        <p:cNvGrpSpPr/>
+        <p:nvPr/>
+      </p:nvGrpSpPr>
+      <p:grpSpPr>
+        <a:xfrm>
+          <a:off x="0" y="0"/>
+          <a:ext cx="0" cy="0"/>
+          <a:chOff x="0" y="0"/>
+          <a:chExt cx="0" cy="0"/>
+        </a:xfrm>
+      </p:grpSpPr>
+      <p:sp>
+        <p:nvSpPr>
+          <p:cNvPr id="2" name="Text 0"/>
+          <p:cNvSpPr/>
+          <p:nvPr/>
+        </p:nvSpPr>
+        <p:spPr>
+          <a:xfrm>
+            <a:off x="457200" y="713232"/>
+            <a:ext cx="11368735" cy="274320"/>
+          </a:xfrm>
+          <a:prstGeom prst="rect">
+            <a:avLst/>
+          </a:prstGeom>
+          <a:noFill/>
+          <a:ln/>
+        </p:spPr>
+        <p:txBody>
+          <a:bodyPr wrap="square" lIns="0" tIns="0" rIns="0" bIns="0" rtlCol="0" anchor="ctr"/>
+          <a:lstStyle/>
+          <a:p>
+            <a:pPr algn="r" indent="0" marL="0">
+              <a:buNone/>
+            </a:pPr>
+            <a:r>
+              <a:rPr lang="en-US" sz="1400" b="1" dirty="0">
+                <a:solidFill>
+                  <a:srgbClr val="1C3F6E"/>
+                </a:solidFill>
+                <a:latin typeface="Calibri" pitchFamily="34" charset="0"/>
+                <a:ea typeface="Calibri" pitchFamily="34" charset="-122"/>
+                <a:cs typeface="Calibri" pitchFamily="34" charset="-120"/>
+              </a:rPr>
+              <a:t>NEXT LESSON</a:t>
+            </a:r>
+            <a:endParaRPr lang="en-US" sz="1400" dirty="0"/>
+          </a:p>
+        </p:txBody>
+      </p:sp>
+      <p:pic>
+        <p:nvPicPr>
+          <p:cNvPr id="3" name="Image 0" descr="/home/claude/f4/img/minesec_sheet.png">    </p:cNvPr>
+          <p:cNvPicPr>
+            <a:picLocks noChangeAspect="1"/>
+          </p:cNvPicPr>
+          <p:nvPr/>
+        </p:nvPicPr>
+        <p:blipFill>
+          <a:blip r:embed="rId1"/>
+          <a:stretch>
+            <a:fillRect/>
+          </a:stretch>
+        </p:blipFill>
+        <p:spPr>
+          <a:xfrm>
+            <a:off x="0" y="658368"/>
+            <a:ext cx="5120640" cy="5833872"/>
+          </a:xfrm>
+          <a:prstGeom prst="rect">
+            <a:avLst/>
+          </a:prstGeom>
+        </p:spPr>
+      </p:pic>
+      <p:sp>
+        <p:nvSpPr>
+          <p:cNvPr id="4" name="Text 1"/>
+          <p:cNvSpPr/>
+          <p:nvPr/>
+        </p:nvSpPr>
+        <p:spPr>
+          <a:xfrm>
+            <a:off x="5349240" y="1005840"/>
+            <a:ext cx="6522415" cy="731520"/>
+          </a:xfrm>
+          <a:prstGeom prst="rect">
+            <a:avLst/>
+          </a:prstGeom>
+          <a:noFill/>
+          <a:ln/>
+        </p:spPr>
+        <p:txBody>
+          <a:bodyPr wrap="square" lIns="0" tIns="0" rIns="0" bIns="0" rtlCol="0" anchor="ctr">
+            <a:normAutofit/>
+          </a:bodyPr>
+          <a:lstStyle/>
+          <a:p>
+            <a:pPr algn="ctr" indent="0" marL="0">
+              <a:buNone/>
+            </a:pPr>
+            <a:r>
+              <a:rPr lang="en-US" sz="3600" b="1" dirty="0">
+                <a:solidFill>
+                  <a:srgbClr val="990011"/>
+                </a:solidFill>
+                <a:latin typeface="Times New Roman" pitchFamily="34" charset="0"/>
+                <a:ea typeface="Times New Roman" pitchFamily="34" charset="-122"/>
+                <a:cs typeface="Times New Roman" pitchFamily="34" charset="-120"/>
+              </a:rPr>
+              <a:t>Next Lesson</a:t>
+            </a:r>
+            <a:endParaRPr lang="en-US" sz="3600" dirty="0"/>
+          </a:p>
+        </p:txBody>
+      </p:sp>
+      <p:sp>
+        <p:nvSpPr>
+          <p:cNvPr id="5" name="Text 2"/>
+          <p:cNvSpPr/>
+          <p:nvPr/>
+        </p:nvSpPr>
+        <p:spPr>
+          <a:xfrm>
+            <a:off x="5349240" y="1783080"/>
+            <a:ext cx="6522415" cy="4663440"/>
+          </a:xfrm>
+          <a:prstGeom prst="rect">
+            <a:avLst/>
+          </a:prstGeom>
+          <a:noFill/>
+          <a:ln/>
+        </p:spPr>
+        <p:txBody>
+          <a:bodyPr wrap="square" lIns="0" tIns="0" rIns="0" bIns="0" rtlCol="0" anchor="ctr"/>
+          <a:lstStyle/>
+          <a:p>
+            <a:pPr algn="ctr" indent="0" marL="0">
+              <a:spcAft>
+                <a:spcPts val="800"/>
+              </a:spcAft>
+              <a:buNone/>
+            </a:pPr>
+            <a:r>
+              <a:rPr lang="en-US" sz="4000" b="1" dirty="0">
+                <a:solidFill>
+                  <a:srgbClr val="111111"/>
+                </a:solidFill>
+                <a:latin typeface="Times New Roman" pitchFamily="34" charset="0"/>
+                <a:ea typeface="Times New Roman" pitchFamily="34" charset="-122"/>
+                <a:cs typeface="Times New Roman" pitchFamily="34" charset="-120"/>
+              </a:rPr>
+              <a:t>Our next lesson will be on:</a:t>
+            </a:r>
+            <a:endParaRPr lang="en-US" sz="4000" dirty="0"/>
+          </a:p>
+          <a:p>
+            <a:pPr algn="ctr" indent="0" marL="0">
+              <a:spcAft>
+                <a:spcPts val="800"/>
+              </a:spcAft>
+              <a:buNone/>
+            </a:pPr>
+            <a:r>
+              <a:rPr lang="en-US" sz="4000" b="1" dirty="0">
+                <a:solidFill>
+                  <a:srgbClr val="990011"/>
+                </a:solidFill>
+                <a:latin typeface="Times New Roman" pitchFamily="34" charset="0"/>
+                <a:ea typeface="Times New Roman" pitchFamily="34" charset="-122"/>
+                <a:cs typeface="Times New Roman" pitchFamily="34" charset="-120"/>
+              </a:rPr>
+              <a:t>Lesson 21: Mountain Climates</a:t>
+            </a:r>
+            <a:endParaRPr lang="en-US" sz="4000" dirty="0"/>
+          </a:p>
+        </p:txBody>
+      </p:sp>
+      <p:sp>
+        <p:nvSpPr>
+          <p:cNvPr id="25" name="Slide Number Placeholder 0"/>
+          <p:cNvSpPr>
+            <a:spLocks noGrp="1"/>
+          </p:cNvSpPr>
+          <p:nvPr>
+            <p:ph type="sldNum" sz="quarter" idx="4294967295"/>
+          </p:nvPr>
+        </p:nvSpPr>
+        <p:spPr>
+          <a:xfrm>
+            <a:off x="27432" y="91440"/>
+            <a:ext cx="585216" cy="475488"/>
+          </a:xfrm>
+          <a:prstGeom prst="rect">
+            <a:avLst/>
+          </a:prstGeom>
+          <a:extLst>
+            <a:ext uri="{C572A759-6A51-4108-AA02-DFA0A04FC94B}">
+              <ma14:wrappingTextBoxFlag xmlns:ma14="http://schemas.microsoft.com/office/mac/drawingml/2011/main" val="0"/>
+            </a:ext>
+          </a:extLst>
+        </p:spPr>
+        <p:txBody>
+          <a:bodyPr/>
+          <a:lstStyle>
+            <a:lvl1pPr>
+              <a:defRPr sz="2000">
+                <a:solidFill>
+                  <a:srgbClr val="FFFFFF"/>
+                </a:solidFill>
+                <a:latin typeface="Calibri"/>
+                <a:ea typeface="Calibri"/>
+                <a:cs typeface="Calibri"/>
+              </a:defRPr>
+            </a:lvl1pPr>
+          </a:lstStyle>
+          <a:p>
+            <a:pPr algn="ctr"/>
+            <a:fld id="{F7021451-1387-4CA6-816F-3879F97B5CBC}" type="slidenum">
+              <a:rPr b="1" lang="en-US"/>
+              <a:t>59</a:t>
+            </a:fld>
+            <a:endParaRPr lang="en-US"/>
+          </a:p>
+        </p:txBody>
+      </p:sp>
+    </p:spTree>
+  </p:cSld>
+  <p:clrMapOvr>
+    <a:masterClrMapping/>
+  </p:clrMapOvr>
+</p:sld>
+</file>
+
+<file path=ppt/slides/slide6.xml><?xml version="1.0" encoding="utf-8"?>
+<p:sld xmlns:a="http://schemas.openxmlformats.org/drawingml/2006/main" xmlns:r="http://schemas.openxmlformats.org/officeDocument/2006/relationships" xmlns:p="http://schemas.openxmlformats.org/presentationml/2006/main">
+  <p:cSld name="Slide 6">
+    <p:spTree>
+      <p:nvGrpSpPr>
+        <p:cNvPr id="1" name=""/>
+        <p:cNvGrpSpPr/>
+        <p:nvPr/>
+      </p:nvGrpSpPr>
+      <p:grpSpPr>
+        <a:xfrm>
+          <a:off x="0" y="0"/>
+          <a:ext cx="0" cy="0"/>
+          <a:chOff x="0" y="0"/>
+          <a:chExt cx="0" cy="0"/>
+        </a:xfrm>
+      </p:grpSpPr>
+      <p:sp>
+        <p:nvSpPr>
+          <p:cNvPr id="2" name="Text 0"/>
+          <p:cNvSpPr/>
+          <p:nvPr/>
+        </p:nvSpPr>
+        <p:spPr>
+          <a:xfrm>
+            <a:off x="457200" y="713232"/>
+            <a:ext cx="11368735" cy="274320"/>
+          </a:xfrm>
+          <a:prstGeom prst="rect">
+            <a:avLst/>
+          </a:prstGeom>
+          <a:noFill/>
+          <a:ln/>
+        </p:spPr>
+        <p:txBody>
+          <a:bodyPr wrap="square" lIns="0" tIns="0" rIns="0" bIns="0" rtlCol="0" anchor="ctr"/>
+          <a:lstStyle/>
+          <a:p>
+            <a:pPr algn="r" indent="0" marL="0">
+              <a:buNone/>
+            </a:pPr>
+            <a:r>
+              <a:rPr lang="en-US" sz="1400" b="1" dirty="0">
+                <a:solidFill>
+                  <a:srgbClr val="1C3F6E"/>
+                </a:solidFill>
+                <a:latin typeface="Calibri" pitchFamily="34" charset="0"/>
+                <a:ea typeface="Calibri" pitchFamily="34" charset="-122"/>
+                <a:cs typeface="Calibri" pitchFamily="34" charset="-120"/>
+              </a:rPr>
+              <a:t>LESSON PLAN</a:t>
+            </a:r>
+            <a:endParaRPr lang="en-US" sz="1400" dirty="0"/>
+          </a:p>
+        </p:txBody>
+      </p:sp>
+      <p:pic>
+        <p:nvPicPr>
+          <p:cNvPr id="3" name="Image 0" descr="/home/claude/f4/img/minesec_sheet.png">    </p:cNvPr>
+          <p:cNvPicPr>
+            <a:picLocks noChangeAspect="1"/>
+          </p:cNvPicPr>
+          <p:nvPr/>
+        </p:nvPicPr>
+        <p:blipFill>
+          <a:blip r:embed="rId1"/>
+          <a:stretch>
+            <a:fillRect/>
+          </a:stretch>
+        </p:blipFill>
+        <p:spPr>
+          <a:xfrm>
+            <a:off x="0" y="658368"/>
+            <a:ext cx="2468880" cy="5833872"/>
+          </a:xfrm>
+          <a:prstGeom prst="rect">
+            <a:avLst/>
+          </a:prstGeom>
+        </p:spPr>
+      </p:pic>
+      <p:sp>
+        <p:nvSpPr>
+          <p:cNvPr id="4" name="Text 1"/>
+          <p:cNvSpPr/>
+          <p:nvPr/>
+        </p:nvSpPr>
+        <p:spPr>
+          <a:xfrm>
+            <a:off x="2697480" y="1005840"/>
+            <a:ext cx="9174175" cy="731520"/>
+          </a:xfrm>
+          <a:prstGeom prst="rect">
+            <a:avLst/>
+          </a:prstGeom>
+          <a:noFill/>
+          <a:ln/>
+        </p:spPr>
+        <p:txBody>
+          <a:bodyPr wrap="square" lIns="0" tIns="0" rIns="0" bIns="0" rtlCol="0" anchor="ctr">
+            <a:normAutofit/>
+          </a:bodyPr>
+          <a:lstStyle/>
+          <a:p>
+            <a:pPr algn="ctr" indent="0" marL="0">
+              <a:buNone/>
+            </a:pPr>
+            <a:r>
+              <a:rPr lang="en-US" sz="3600" b="1" dirty="0">
+                <a:solidFill>
+                  <a:srgbClr val="990011"/>
+                </a:solidFill>
+                <a:latin typeface="Times New Roman" pitchFamily="34" charset="0"/>
+                <a:ea typeface="Times New Roman" pitchFamily="34" charset="-122"/>
+                <a:cs typeface="Times New Roman" pitchFamily="34" charset="-120"/>
+              </a:rPr>
+              <a:t>Lesson Plan</a:t>
+            </a:r>
+            <a:endParaRPr lang="en-US" sz="3600" dirty="0"/>
+          </a:p>
+        </p:txBody>
+      </p:sp>
+      <p:sp>
+        <p:nvSpPr>
+          <p:cNvPr id="5" name="Text 2"/>
+          <p:cNvSpPr/>
+          <p:nvPr/>
+        </p:nvSpPr>
+        <p:spPr>
+          <a:xfrm>
+            <a:off x="2697480" y="1783080"/>
+            <a:ext cx="9174175" cy="4663440"/>
+          </a:xfrm>
+          <a:prstGeom prst="rect">
+            <a:avLst/>
+          </a:prstGeom>
+          <a:noFill/>
+          <a:ln/>
+        </p:spPr>
+        <p:txBody>
+          <a:bodyPr wrap="square" lIns="0" tIns="0" rIns="0" bIns="0" rtlCol="0" anchor="t"/>
+          <a:lstStyle/>
+          <a:p>
+            <a:pPr algn="l" marL="342900" indent="-342900">
+              <a:spcAft>
+                <a:spcPts val="800"/>
+              </a:spcAft>
+              <a:buSzPct val="100000"/>
+              <a:buFont typeface="+mj-lt"/>
+              <a:buAutoNum type="arabicPeriod" startAt="1"/>
+            </a:pPr>
+            <a:r>
+              <a:rPr lang="en-US" sz="4000" dirty="0">
+                <a:solidFill>
+                  <a:srgbClr val="111111"/>
+                </a:solidFill>
+                <a:latin typeface="Times New Roman" pitchFamily="34" charset="0"/>
+                <a:ea typeface="Times New Roman" pitchFamily="34" charset="-122"/>
+                <a:cs typeface="Times New Roman" pitchFamily="34" charset="-120"/>
+              </a:rPr>
+              <a:t>Correction of the homework</a:t>
+            </a:r>
+            <a:endParaRPr lang="en-US" sz="4000" dirty="0"/>
+          </a:p>
+          <a:p>
+            <a:pPr algn="l" marL="342900" indent="-342900">
+              <a:spcAft>
+                <a:spcPts val="800"/>
+              </a:spcAft>
+              <a:buSzPct val="100000"/>
+              <a:buFont typeface="+mj-lt"/>
+              <a:buAutoNum type="arabicPeriod" startAt="1"/>
+            </a:pPr>
+            <a:r>
+              <a:rPr lang="en-US" sz="4000" dirty="0">
+                <a:solidFill>
+                  <a:srgbClr val="111111"/>
+                </a:solidFill>
+                <a:latin typeface="Times New Roman" pitchFamily="34" charset="0"/>
+                <a:ea typeface="Times New Roman" pitchFamily="34" charset="-122"/>
+                <a:cs typeface="Times New Roman" pitchFamily="34" charset="-120"/>
+              </a:rPr>
+              <a:t>Objectives and recall</a:t>
+            </a:r>
+            <a:endParaRPr lang="en-US" sz="4000" dirty="0"/>
+          </a:p>
+          <a:p>
+            <a:pPr algn="l" marL="342900" indent="-342900">
+              <a:spcAft>
+                <a:spcPts val="800"/>
+              </a:spcAft>
+              <a:buSzPct val="100000"/>
+              <a:buFont typeface="+mj-lt"/>
+              <a:buAutoNum type="arabicPeriod" startAt="1"/>
+            </a:pPr>
+            <a:r>
+              <a:rPr lang="en-US" sz="4000" dirty="0">
+                <a:solidFill>
+                  <a:srgbClr val="111111"/>
+                </a:solidFill>
+                <a:latin typeface="Times New Roman" pitchFamily="34" charset="0"/>
+                <a:ea typeface="Times New Roman" pitchFamily="34" charset="-122"/>
+                <a:cs typeface="Times New Roman" pitchFamily="34" charset="-120"/>
+              </a:rPr>
+              <a:t>Real-life situation and action to take</a:t>
+            </a:r>
+            <a:endParaRPr lang="en-US" sz="4000" dirty="0"/>
+          </a:p>
+          <a:p>
+            <a:pPr algn="l" marL="342900" indent="-342900">
+              <a:spcAft>
+                <a:spcPts val="800"/>
+              </a:spcAft>
+              <a:buSzPct val="100000"/>
+              <a:buFont typeface="+mj-lt"/>
+              <a:buAutoNum type="arabicPeriod" startAt="1"/>
+            </a:pPr>
+            <a:r>
+              <a:rPr lang="en-US" sz="4000" dirty="0">
+                <a:solidFill>
+                  <a:srgbClr val="111111"/>
+                </a:solidFill>
+                <a:latin typeface="Times New Roman" pitchFamily="34" charset="0"/>
+                <a:ea typeface="Times New Roman" pitchFamily="34" charset="-122"/>
+                <a:cs typeface="Times New Roman" pitchFamily="34" charset="-120"/>
+              </a:rPr>
+              <a:t>Learning activities</a:t>
+            </a:r>
+            <a:endParaRPr lang="en-US" sz="4000" dirty="0"/>
+          </a:p>
+          <a:p>
+            <a:pPr algn="l" marL="342900" indent="-342900">
+              <a:spcAft>
+                <a:spcPts val="800"/>
+              </a:spcAft>
+              <a:buSzPct val="100000"/>
+              <a:buFont typeface="+mj-lt"/>
+              <a:buAutoNum type="arabicPeriod" startAt="1"/>
+            </a:pPr>
+            <a:r>
+              <a:rPr lang="en-US" sz="4000" dirty="0">
+                <a:solidFill>
+                  <a:srgbClr val="111111"/>
+                </a:solidFill>
+                <a:latin typeface="Times New Roman" pitchFamily="34" charset="0"/>
+                <a:ea typeface="Times New Roman" pitchFamily="34" charset="-122"/>
+                <a:cs typeface="Times New Roman" pitchFamily="34" charset="-120"/>
+              </a:rPr>
+              <a:t>Board summary</a:t>
+            </a:r>
+            <a:endParaRPr lang="en-US" sz="4000" dirty="0"/>
+          </a:p>
+          <a:p>
+            <a:pPr algn="l" marL="342900" indent="-342900">
+              <a:spcAft>
+                <a:spcPts val="800"/>
+              </a:spcAft>
+              <a:buSzPct val="100000"/>
+              <a:buFont typeface="+mj-lt"/>
+              <a:buAutoNum type="arabicPeriod" startAt="1"/>
+            </a:pPr>
+            <a:r>
+              <a:rPr lang="en-US" sz="4000" dirty="0">
+                <a:solidFill>
+                  <a:srgbClr val="111111"/>
+                </a:solidFill>
+                <a:latin typeface="Times New Roman" pitchFamily="34" charset="0"/>
+                <a:ea typeface="Times New Roman" pitchFamily="34" charset="-122"/>
+                <a:cs typeface="Times New Roman" pitchFamily="34" charset="-120"/>
+              </a:rPr>
+              <a:t>Evaluation, remediation and homework</a:t>
+            </a:r>
+            <a:endParaRPr lang="en-US" sz="4000" dirty="0"/>
+          </a:p>
+        </p:txBody>
+      </p:sp>
+      <p:sp>
+        <p:nvSpPr>
+          <p:cNvPr id="25" name="Slide Number Placeholder 0"/>
+          <p:cNvSpPr>
+            <a:spLocks noGrp="1"/>
+          </p:cNvSpPr>
+          <p:nvPr>
+            <p:ph type="sldNum" sz="quarter" idx="4294967295"/>
+          </p:nvPr>
+        </p:nvSpPr>
+        <p:spPr>
+          <a:xfrm>
+            <a:off x="27432" y="91440"/>
+            <a:ext cx="585216" cy="475488"/>
+          </a:xfrm>
+          <a:prstGeom prst="rect">
+            <a:avLst/>
+          </a:prstGeom>
+          <a:extLst>
+            <a:ext uri="{C572A759-6A51-4108-AA02-DFA0A04FC94B}">
+              <ma14:wrappingTextBoxFlag xmlns:ma14="http://schemas.microsoft.com/office/mac/drawingml/2011/main" val="0"/>
+            </a:ext>
+          </a:extLst>
+        </p:spPr>
+        <p:txBody>
+          <a:bodyPr/>
+          <a:lstStyle>
+            <a:lvl1pPr>
+              <a:defRPr sz="2000">
+                <a:solidFill>
+                  <a:srgbClr val="FFFFFF"/>
+                </a:solidFill>
+                <a:latin typeface="Calibri"/>
+                <a:ea typeface="Calibri"/>
+                <a:cs typeface="Calibri"/>
+              </a:defRPr>
+            </a:lvl1pPr>
+          </a:lstStyle>
+          <a:p>
+            <a:pPr algn="ctr"/>
+            <a:fld id="{F7021451-1387-4CA6-816F-3879F97B5CBC}" type="slidenum">
+              <a:rPr b="1" lang="en-US"/>
+              <a:t>6</a:t>
+            </a:fld>
+            <a:endParaRPr lang="en-US"/>
+          </a:p>
+        </p:txBody>
+      </p:sp>
+    </p:spTree>
+  </p:cSld>
+  <p:clrMapOvr>
+    <a:masterClrMapping/>
+  </p:clrMapOvr>
+</p:sld>
+</file>
+
+<file path=ppt/slides/slide60.xml><?xml version="1.0" encoding="utf-8"?>
+<p:sld xmlns:a="http://schemas.openxmlformats.org/drawingml/2006/main" xmlns:r="http://schemas.openxmlformats.org/officeDocument/2006/relationships" xmlns:p="http://schemas.openxmlformats.org/presentationml/2006/main">
+  <p:cSld name="Slide 60">
+    <p:spTree>
+      <p:nvGrpSpPr>
+        <p:cNvPr id="1" name=""/>
+        <p:cNvGrpSpPr/>
+        <p:nvPr/>
+      </p:nvGrpSpPr>
+      <p:grpSpPr>
+        <a:xfrm>
+          <a:off x="0" y="0"/>
+          <a:ext cx="0" cy="0"/>
+          <a:chOff x="0" y="0"/>
+          <a:chExt cx="0" cy="0"/>
+        </a:xfrm>
+      </p:grpSpPr>
+      <p:sp>
+        <p:nvSpPr>
+          <p:cNvPr id="2" name="Text 0"/>
+          <p:cNvSpPr/>
+          <p:nvPr/>
+        </p:nvSpPr>
+        <p:spPr>
+          <a:xfrm>
+            <a:off x="457200" y="713232"/>
+            <a:ext cx="11368735" cy="274320"/>
+          </a:xfrm>
+          <a:prstGeom prst="rect">
+            <a:avLst/>
+          </a:prstGeom>
+          <a:noFill/>
+          <a:ln/>
+        </p:spPr>
+        <p:txBody>
+          <a:bodyPr wrap="square" lIns="0" tIns="0" rIns="0" bIns="0" rtlCol="0" anchor="ctr"/>
+          <a:lstStyle/>
+          <a:p>
+            <a:pPr algn="r" indent="0" marL="0">
+              <a:buNone/>
+            </a:pPr>
+            <a:r>
+              <a:rPr lang="en-US" sz="1400" b="1" dirty="0">
+                <a:solidFill>
+                  <a:srgbClr val="1C3F6E"/>
+                </a:solidFill>
+                <a:latin typeface="Calibri" pitchFamily="34" charset="0"/>
+                <a:ea typeface="Calibri" pitchFamily="34" charset="-122"/>
+                <a:cs typeface="Calibri" pitchFamily="34" charset="-120"/>
+              </a:rPr>
               <a:t>BILINGUAL GAME</a:t>
             </a:r>
             <a:endParaRPr lang="en-US" sz="1400" dirty="0"/>
@@ -20134,7 +21637,7 @@
       </p:sp>
       <p:graphicFrame>
         <p:nvGraphicFramePr>
-          <p:cNvPr id="57" name="Table 0"/>
+          <p:cNvPr id="61" name="Table 0"/>
           <p:cNvGraphicFramePr>
             <a:graphicFrameLocks noGrp="1"/>
           </p:cNvGraphicFramePr>
@@ -21170,7 +22673,7 @@
             <a:pPr algn="ctr"/>
             <a:fld id="{F7021451-1387-4CA6-816F-3879F97B5CBC}" type="slidenum">
               <a:rPr b="1" lang="en-US"/>
-              <a:t>56</a:t>
+              <a:t>60</a:t>
             </a:fld>
             <a:endParaRPr lang="en-US"/>
           </a:p>
@@ -21184,9 +22687,9 @@
 </p:sld>
 </file>
 
-<file path=ppt/slides/slide57.xml><?xml version="1.0" encoding="utf-8"?>
+<file path=ppt/slides/slide61.xml><?xml version="1.0" encoding="utf-8"?>
 <p:sld xmlns:a="http://schemas.openxmlformats.org/drawingml/2006/main" xmlns:r="http://schemas.openxmlformats.org/officeDocument/2006/relationships" xmlns:p="http://schemas.openxmlformats.org/presentationml/2006/main">
-  <p:cSld name="Slide 57">
+  <p:cSld name="Slide 61">
     <p:spTree>
       <p:nvGrpSpPr>
         <p:cNvPr id="1" name=""/>
@@ -21281,7 +22784,7 @@
       </p:sp>
       <p:graphicFrame>
         <p:nvGraphicFramePr>
-          <p:cNvPr id="58" name="Table 0"/>
+          <p:cNvPr id="62" name="Table 0"/>
           <p:cNvGraphicFramePr>
             <a:graphicFrameLocks noGrp="1"/>
           </p:cNvGraphicFramePr>
@@ -21903,7 +23406,7 @@
             <a:pPr algn="ctr"/>
             <a:fld id="{F7021451-1387-4CA6-816F-3879F97B5CBC}" type="slidenum">
               <a:rPr b="1" lang="en-US"/>
-              <a:t>57</a:t>
+              <a:t>61</a:t>
             </a:fld>
             <a:endParaRPr lang="en-US"/>
           </a:p>
@@ -21917,9 +23420,9 @@
 </p:sld>
 </file>
 
-<file path=ppt/slides/slide58.xml><?xml version="1.0" encoding="utf-8"?>
+<file path=ppt/slides/slide62.xml><?xml version="1.0" encoding="utf-8"?>
 <p:sld xmlns:a="http://schemas.openxmlformats.org/drawingml/2006/main" xmlns:r="http://schemas.openxmlformats.org/officeDocument/2006/relationships" xmlns:p="http://schemas.openxmlformats.org/presentationml/2006/main">
-  <p:cSld name="Slide 58">
+  <p:cSld name="Slide 62">
     <p:spTree>
       <p:nvGrpSpPr>
         <p:cNvPr id="1" name=""/>
@@ -22014,7 +23517,7 @@
       </p:sp>
       <p:graphicFrame>
         <p:nvGraphicFramePr>
-          <p:cNvPr id="59" name="Table 0"/>
+          <p:cNvPr id="63" name="Table 0"/>
           <p:cNvGraphicFramePr>
             <a:graphicFrameLocks noGrp="1"/>
           </p:cNvGraphicFramePr>
@@ -22124,7 +23627,7 @@
                           <a:ea typeface="Calibri" pitchFamily="34" charset="-122"/>
                           <a:cs typeface="Calibri" pitchFamily="34" charset="-120"/>
                         </a:rPr>
-                        <a:t>DEFINITIONS; Meaning and Classification of Micro-climates; Characteristics of Urban Climates; Factors of the Urban Heat Island.</a:t>
+                        <a:t>DEFINITIONS; Meaning of Micro-climates; Classification of Micro-climates; Characteristics of Urban Climates; Factors of Urban Climates.</a:t>
                       </a:r>
                       <a:endParaRPr lang="en-US" sz="1600" dirty="0">
                         <a:latin typeface="Calibri" charset="0"/>
@@ -22774,7 +24277,7 @@
             <a:pPr algn="ctr"/>
             <a:fld id="{F7021451-1387-4CA6-816F-3879F97B5CBC}" type="slidenum">
               <a:rPr b="1" lang="en-US"/>
-              <a:t>58</a:t>
+              <a:t>62</a:t>
             </a:fld>
             <a:endParaRPr lang="en-US"/>
           </a:p>
@@ -22788,9 +24291,9 @@
 </p:sld>
 </file>
 
-<file path=ppt/slides/slide59.xml><?xml version="1.0" encoding="utf-8"?>
+<file path=ppt/slides/slide63.xml><?xml version="1.0" encoding="utf-8"?>
 <p:sld xmlns:a="http://schemas.openxmlformats.org/drawingml/2006/main" xmlns:r="http://schemas.openxmlformats.org/officeDocument/2006/relationships" xmlns:p="http://schemas.openxmlformats.org/presentationml/2006/main">
-  <p:cSld name="Slide 59">
+  <p:cSld name="Slide 63">
     <p:spTree>
       <p:nvGrpSpPr>
         <p:cNvPr id="1" name=""/>
@@ -23099,7 +24602,7 @@
             <a:pPr algn="ctr"/>
             <a:fld id="{F7021451-1387-4CA6-816F-3879F97B5CBC}" type="slidenum">
               <a:rPr b="1" lang="en-US"/>
-              <a:t>59</a:t>
+              <a:t>63</a:t>
             </a:fld>
             <a:endParaRPr lang="en-US"/>
           </a:p>
@@ -23113,9 +24616,9 @@
 </p:sld>
 </file>
 
-<file path=ppt/slides/slide6.xml><?xml version="1.0" encoding="utf-8"?>
+<file path=ppt/slides/slide64.xml><?xml version="1.0" encoding="utf-8"?>
 <p:sld xmlns:a="http://schemas.openxmlformats.org/drawingml/2006/main" xmlns:r="http://schemas.openxmlformats.org/officeDocument/2006/relationships" xmlns:p="http://schemas.openxmlformats.org/presentationml/2006/main">
-  <p:cSld name="Slide 6">
+  <p:cSld name="Slide 64">
     <p:spTree>
       <p:nvGrpSpPr>
         <p:cNvPr id="1" name=""/>
@@ -23163,7 +24666,7 @@
                 <a:ea typeface="Calibri" pitchFamily="34" charset="-122"/>
                 <a:cs typeface="Calibri" pitchFamily="34" charset="-120"/>
               </a:rPr>
-              <a:t>LESSON PLAN</a:t>
+              <a:t>REFERENCES</a:t>
             </a:r>
             <a:endParaRPr lang="en-US" sz="1400" dirty="0"/>
           </a:p>
@@ -23186,337 +24689,6 @@
         <p:spPr>
           <a:xfrm>
             <a:off x="0" y="658368"/>
-            <a:ext cx="2468880" cy="5833872"/>
-          </a:xfrm>
-          <a:prstGeom prst="rect">
-            <a:avLst/>
-          </a:prstGeom>
-        </p:spPr>
-      </p:pic>
-      <p:sp>
-        <p:nvSpPr>
-          <p:cNvPr id="4" name="Text 1"/>
-          <p:cNvSpPr/>
-          <p:nvPr/>
-        </p:nvSpPr>
-        <p:spPr>
-          <a:xfrm>
-            <a:off x="2697480" y="1005840"/>
-            <a:ext cx="9174175" cy="731520"/>
-          </a:xfrm>
-          <a:prstGeom prst="rect">
-            <a:avLst/>
-          </a:prstGeom>
-          <a:noFill/>
-          <a:ln/>
-        </p:spPr>
-        <p:txBody>
-          <a:bodyPr wrap="square" lIns="0" tIns="0" rIns="0" bIns="0" rtlCol="0" anchor="ctr">
-            <a:normAutofit/>
-          </a:bodyPr>
-          <a:lstStyle/>
-          <a:p>
-            <a:pPr algn="ctr" indent="0" marL="0">
-              <a:buNone/>
-            </a:pPr>
-            <a:r>
-              <a:rPr lang="en-US" sz="3600" b="1" dirty="0">
-                <a:solidFill>
-                  <a:srgbClr val="990011"/>
-                </a:solidFill>
-                <a:latin typeface="Times New Roman" pitchFamily="34" charset="0"/>
-                <a:ea typeface="Times New Roman" pitchFamily="34" charset="-122"/>
-                <a:cs typeface="Times New Roman" pitchFamily="34" charset="-120"/>
-              </a:rPr>
-              <a:t>Lesson Plan</a:t>
-            </a:r>
-            <a:endParaRPr lang="en-US" sz="3600" dirty="0"/>
-          </a:p>
-        </p:txBody>
-      </p:sp>
-      <p:sp>
-        <p:nvSpPr>
-          <p:cNvPr id="5" name="Text 2"/>
-          <p:cNvSpPr/>
-          <p:nvPr/>
-        </p:nvSpPr>
-        <p:spPr>
-          <a:xfrm>
-            <a:off x="2697480" y="1783080"/>
-            <a:ext cx="9174175" cy="4663440"/>
-          </a:xfrm>
-          <a:prstGeom prst="rect">
-            <a:avLst/>
-          </a:prstGeom>
-          <a:noFill/>
-          <a:ln/>
-        </p:spPr>
-        <p:txBody>
-          <a:bodyPr wrap="square" lIns="0" tIns="0" rIns="0" bIns="0" rtlCol="0" anchor="t"/>
-          <a:lstStyle/>
-          <a:p>
-            <a:pPr algn="l" marL="342900" indent="-342900">
-              <a:spcAft>
-                <a:spcPts val="800"/>
-              </a:spcAft>
-              <a:buSzPct val="100000"/>
-              <a:buFont typeface="+mj-lt"/>
-              <a:buAutoNum type="arabicPeriod" startAt="1"/>
-            </a:pPr>
-            <a:r>
-              <a:rPr lang="en-US" sz="4000" dirty="0">
-                <a:solidFill>
-                  <a:srgbClr val="111111"/>
-                </a:solidFill>
-                <a:latin typeface="Times New Roman" pitchFamily="34" charset="0"/>
-                <a:ea typeface="Times New Roman" pitchFamily="34" charset="-122"/>
-                <a:cs typeface="Times New Roman" pitchFamily="34" charset="-120"/>
-              </a:rPr>
-              <a:t>Correction of the homework</a:t>
-            </a:r>
-            <a:endParaRPr lang="en-US" sz="4000" dirty="0"/>
-          </a:p>
-          <a:p>
-            <a:pPr algn="l" marL="342900" indent="-342900">
-              <a:spcAft>
-                <a:spcPts val="800"/>
-              </a:spcAft>
-              <a:buSzPct val="100000"/>
-              <a:buFont typeface="+mj-lt"/>
-              <a:buAutoNum type="arabicPeriod" startAt="1"/>
-            </a:pPr>
-            <a:r>
-              <a:rPr lang="en-US" sz="4000" dirty="0">
-                <a:solidFill>
-                  <a:srgbClr val="111111"/>
-                </a:solidFill>
-                <a:latin typeface="Times New Roman" pitchFamily="34" charset="0"/>
-                <a:ea typeface="Times New Roman" pitchFamily="34" charset="-122"/>
-                <a:cs typeface="Times New Roman" pitchFamily="34" charset="-120"/>
-              </a:rPr>
-              <a:t>Objectives and recall</a:t>
-            </a:r>
-            <a:endParaRPr lang="en-US" sz="4000" dirty="0"/>
-          </a:p>
-          <a:p>
-            <a:pPr algn="l" marL="342900" indent="-342900">
-              <a:spcAft>
-                <a:spcPts val="800"/>
-              </a:spcAft>
-              <a:buSzPct val="100000"/>
-              <a:buFont typeface="+mj-lt"/>
-              <a:buAutoNum type="arabicPeriod" startAt="1"/>
-            </a:pPr>
-            <a:r>
-              <a:rPr lang="en-US" sz="4000" dirty="0">
-                <a:solidFill>
-                  <a:srgbClr val="111111"/>
-                </a:solidFill>
-                <a:latin typeface="Times New Roman" pitchFamily="34" charset="0"/>
-                <a:ea typeface="Times New Roman" pitchFamily="34" charset="-122"/>
-                <a:cs typeface="Times New Roman" pitchFamily="34" charset="-120"/>
-              </a:rPr>
-              <a:t>Real-life situation and action to take</a:t>
-            </a:r>
-            <a:endParaRPr lang="en-US" sz="4000" dirty="0"/>
-          </a:p>
-          <a:p>
-            <a:pPr algn="l" marL="342900" indent="-342900">
-              <a:spcAft>
-                <a:spcPts val="800"/>
-              </a:spcAft>
-              <a:buSzPct val="100000"/>
-              <a:buFont typeface="+mj-lt"/>
-              <a:buAutoNum type="arabicPeriod" startAt="1"/>
-            </a:pPr>
-            <a:r>
-              <a:rPr lang="en-US" sz="4000" dirty="0">
-                <a:solidFill>
-                  <a:srgbClr val="111111"/>
-                </a:solidFill>
-                <a:latin typeface="Times New Roman" pitchFamily="34" charset="0"/>
-                <a:ea typeface="Times New Roman" pitchFamily="34" charset="-122"/>
-                <a:cs typeface="Times New Roman" pitchFamily="34" charset="-120"/>
-              </a:rPr>
-              <a:t>Learning activities</a:t>
-            </a:r>
-            <a:endParaRPr lang="en-US" sz="4000" dirty="0"/>
-          </a:p>
-          <a:p>
-            <a:pPr algn="l" marL="342900" indent="-342900">
-              <a:spcAft>
-                <a:spcPts val="800"/>
-              </a:spcAft>
-              <a:buSzPct val="100000"/>
-              <a:buFont typeface="+mj-lt"/>
-              <a:buAutoNum type="arabicPeriod" startAt="1"/>
-            </a:pPr>
-            <a:r>
-              <a:rPr lang="en-US" sz="4000" dirty="0">
-                <a:solidFill>
-                  <a:srgbClr val="111111"/>
-                </a:solidFill>
-                <a:latin typeface="Times New Roman" pitchFamily="34" charset="0"/>
-                <a:ea typeface="Times New Roman" pitchFamily="34" charset="-122"/>
-                <a:cs typeface="Times New Roman" pitchFamily="34" charset="-120"/>
-              </a:rPr>
-              <a:t>Board summary</a:t>
-            </a:r>
-            <a:endParaRPr lang="en-US" sz="4000" dirty="0"/>
-          </a:p>
-          <a:p>
-            <a:pPr algn="l" marL="342900" indent="-342900">
-              <a:spcAft>
-                <a:spcPts val="800"/>
-              </a:spcAft>
-              <a:buSzPct val="100000"/>
-              <a:buFont typeface="+mj-lt"/>
-              <a:buAutoNum type="arabicPeriod" startAt="1"/>
-            </a:pPr>
-            <a:r>
-              <a:rPr lang="en-US" sz="4000" dirty="0">
-                <a:solidFill>
-                  <a:srgbClr val="111111"/>
-                </a:solidFill>
-                <a:latin typeface="Times New Roman" pitchFamily="34" charset="0"/>
-                <a:ea typeface="Times New Roman" pitchFamily="34" charset="-122"/>
-                <a:cs typeface="Times New Roman" pitchFamily="34" charset="-120"/>
-              </a:rPr>
-              <a:t>Evaluation, remediation and homework</a:t>
-            </a:r>
-            <a:endParaRPr lang="en-US" sz="4000" dirty="0"/>
-          </a:p>
-        </p:txBody>
-      </p:sp>
-      <p:sp>
-        <p:nvSpPr>
-          <p:cNvPr id="25" name="Slide Number Placeholder 0"/>
-          <p:cNvSpPr>
-            <a:spLocks noGrp="1"/>
-          </p:cNvSpPr>
-          <p:nvPr>
-            <p:ph type="sldNum" sz="quarter" idx="4294967295"/>
-          </p:nvPr>
-        </p:nvSpPr>
-        <p:spPr>
-          <a:xfrm>
-            <a:off x="27432" y="91440"/>
-            <a:ext cx="585216" cy="475488"/>
-          </a:xfrm>
-          <a:prstGeom prst="rect">
-            <a:avLst/>
-          </a:prstGeom>
-          <a:extLst>
-            <a:ext uri="{C572A759-6A51-4108-AA02-DFA0A04FC94B}">
-              <ma14:wrappingTextBoxFlag xmlns:ma14="http://schemas.microsoft.com/office/mac/drawingml/2011/main" val="0"/>
-            </a:ext>
-          </a:extLst>
-        </p:spPr>
-        <p:txBody>
-          <a:bodyPr/>
-          <a:lstStyle>
-            <a:lvl1pPr>
-              <a:defRPr sz="2000">
-                <a:solidFill>
-                  <a:srgbClr val="FFFFFF"/>
-                </a:solidFill>
-                <a:latin typeface="Calibri"/>
-                <a:ea typeface="Calibri"/>
-                <a:cs typeface="Calibri"/>
-              </a:defRPr>
-            </a:lvl1pPr>
-          </a:lstStyle>
-          <a:p>
-            <a:pPr algn="ctr"/>
-            <a:fld id="{F7021451-1387-4CA6-816F-3879F97B5CBC}" type="slidenum">
-              <a:rPr b="1" lang="en-US"/>
-              <a:t>6</a:t>
-            </a:fld>
-            <a:endParaRPr lang="en-US"/>
-          </a:p>
-        </p:txBody>
-      </p:sp>
-    </p:spTree>
-  </p:cSld>
-  <p:clrMapOvr>
-    <a:masterClrMapping/>
-  </p:clrMapOvr>
-</p:sld>
-</file>
-
-<file path=ppt/slides/slide60.xml><?xml version="1.0" encoding="utf-8"?>
-<p:sld xmlns:a="http://schemas.openxmlformats.org/drawingml/2006/main" xmlns:r="http://schemas.openxmlformats.org/officeDocument/2006/relationships" xmlns:p="http://schemas.openxmlformats.org/presentationml/2006/main">
-  <p:cSld name="Slide 60">
-    <p:spTree>
-      <p:nvGrpSpPr>
-        <p:cNvPr id="1" name=""/>
-        <p:cNvGrpSpPr/>
-        <p:nvPr/>
-      </p:nvGrpSpPr>
-      <p:grpSpPr>
-        <a:xfrm>
-          <a:off x="0" y="0"/>
-          <a:ext cx="0" cy="0"/>
-          <a:chOff x="0" y="0"/>
-          <a:chExt cx="0" cy="0"/>
-        </a:xfrm>
-      </p:grpSpPr>
-      <p:sp>
-        <p:nvSpPr>
-          <p:cNvPr id="2" name="Text 0"/>
-          <p:cNvSpPr/>
-          <p:nvPr/>
-        </p:nvSpPr>
-        <p:spPr>
-          <a:xfrm>
-            <a:off x="457200" y="713232"/>
-            <a:ext cx="11368735" cy="274320"/>
-          </a:xfrm>
-          <a:prstGeom prst="rect">
-            <a:avLst/>
-          </a:prstGeom>
-          <a:noFill/>
-          <a:ln/>
-        </p:spPr>
-        <p:txBody>
-          <a:bodyPr wrap="square" lIns="0" tIns="0" rIns="0" bIns="0" rtlCol="0" anchor="ctr"/>
-          <a:lstStyle/>
-          <a:p>
-            <a:pPr algn="r" indent="0" marL="0">
-              <a:buNone/>
-            </a:pPr>
-            <a:r>
-              <a:rPr lang="en-US" sz="1400" b="1" dirty="0">
-                <a:solidFill>
-                  <a:srgbClr val="1C3F6E"/>
-                </a:solidFill>
-                <a:latin typeface="Calibri" pitchFamily="34" charset="0"/>
-                <a:ea typeface="Calibri" pitchFamily="34" charset="-122"/>
-                <a:cs typeface="Calibri" pitchFamily="34" charset="-120"/>
-              </a:rPr>
-              <a:t>REFERENCES</a:t>
-            </a:r>
-            <a:endParaRPr lang="en-US" sz="1400" dirty="0"/>
-          </a:p>
-        </p:txBody>
-      </p:sp>
-      <p:pic>
-        <p:nvPicPr>
-          <p:cNvPr id="3" name="Image 0" descr="/home/claude/f4/img/minesec_sheet.png">    </p:cNvPr>
-          <p:cNvPicPr>
-            <a:picLocks noChangeAspect="1"/>
-          </p:cNvPicPr>
-          <p:nvPr/>
-        </p:nvPicPr>
-        <p:blipFill>
-          <a:blip r:embed="rId1"/>
-          <a:stretch>
-            <a:fillRect/>
-          </a:stretch>
-        </p:blipFill>
-        <p:spPr>
-          <a:xfrm>
-            <a:off x="0" y="658368"/>
             <a:ext cx="3840480" cy="5833872"/>
           </a:xfrm>
           <a:prstGeom prst="rect">
@@ -23755,7 +24927,7 @@
             <a:pPr algn="ctr"/>
             <a:fld id="{F7021451-1387-4CA6-816F-3879F97B5CBC}" type="slidenum">
               <a:rPr b="1" lang="en-US"/>
-              <a:t>60</a:t>
+              <a:t>64</a:t>
             </a:fld>
             <a:endParaRPr lang="en-US"/>
           </a:p>

</xml_diff>